<commit_message>
PPTX has progressed from 'only verifying table-like positive examples' to 'constraining table-like candidate boundaries with both positive and negative examples, and marking them in the README'
</commit_message>
<xml_diff>
--- a/samples/pptx/pptx_table_like_negative_two_column_labels.pptx
+++ b/samples/pptx/pptx_table_like_negative_two_column_labels.pptx
@@ -39,7 +39,7 @@
         <a:uFillTx/>
       </a:defRPr>
     </a:defPPr>
-    <a:lvl1pPr marL="0" marR="0" indent="0" algn="l" defTabSz="2438338" rtl="0" fontAlgn="auto" latinLnBrk="0" hangingPunct="0">
+    <a:lvl1pPr marL="0" marR="0" indent="0" algn="l" defTabSz="2438337" rtl="0" fontAlgn="auto" latinLnBrk="0" hangingPunct="0">
       <a:lnSpc>
         <a:spcPct val="90000"/>
       </a:lnSpc>
@@ -69,7 +69,7 @@
         <a:sym typeface="Helvetica Neue"/>
       </a:defRPr>
     </a:lvl1pPr>
-    <a:lvl2pPr marL="0" marR="0" indent="457200" algn="l" defTabSz="2438338" rtl="0" fontAlgn="auto" latinLnBrk="0" hangingPunct="0">
+    <a:lvl2pPr marL="0" marR="0" indent="0" algn="l" defTabSz="2438337" rtl="0" fontAlgn="auto" latinLnBrk="0" hangingPunct="0">
       <a:lnSpc>
         <a:spcPct val="90000"/>
       </a:lnSpc>
@@ -99,7 +99,7 @@
         <a:sym typeface="Helvetica Neue"/>
       </a:defRPr>
     </a:lvl2pPr>
-    <a:lvl3pPr marL="0" marR="0" indent="914400" algn="l" defTabSz="2438338" rtl="0" fontAlgn="auto" latinLnBrk="0" hangingPunct="0">
+    <a:lvl3pPr marL="0" marR="0" indent="0" algn="l" defTabSz="2438337" rtl="0" fontAlgn="auto" latinLnBrk="0" hangingPunct="0">
       <a:lnSpc>
         <a:spcPct val="90000"/>
       </a:lnSpc>
@@ -129,7 +129,7 @@
         <a:sym typeface="Helvetica Neue"/>
       </a:defRPr>
     </a:lvl3pPr>
-    <a:lvl4pPr marL="0" marR="0" indent="1371600" algn="l" defTabSz="2438338" rtl="0" fontAlgn="auto" latinLnBrk="0" hangingPunct="0">
+    <a:lvl4pPr marL="0" marR="0" indent="0" algn="l" defTabSz="2438337" rtl="0" fontAlgn="auto" latinLnBrk="0" hangingPunct="0">
       <a:lnSpc>
         <a:spcPct val="90000"/>
       </a:lnSpc>
@@ -159,7 +159,7 @@
         <a:sym typeface="Helvetica Neue"/>
       </a:defRPr>
     </a:lvl4pPr>
-    <a:lvl5pPr marL="0" marR="0" indent="1828800" algn="l" defTabSz="2438338" rtl="0" fontAlgn="auto" latinLnBrk="0" hangingPunct="0">
+    <a:lvl5pPr marL="0" marR="0" indent="0" algn="l" defTabSz="2438337" rtl="0" fontAlgn="auto" latinLnBrk="0" hangingPunct="0">
       <a:lnSpc>
         <a:spcPct val="90000"/>
       </a:lnSpc>
@@ -189,7 +189,7 @@
         <a:sym typeface="Helvetica Neue"/>
       </a:defRPr>
     </a:lvl5pPr>
-    <a:lvl6pPr marL="0" marR="0" indent="2286000" algn="l" defTabSz="2438338" rtl="0" fontAlgn="auto" latinLnBrk="0" hangingPunct="0">
+    <a:lvl6pPr marL="0" marR="0" indent="0" algn="l" defTabSz="2438337" rtl="0" fontAlgn="auto" latinLnBrk="0" hangingPunct="0">
       <a:lnSpc>
         <a:spcPct val="90000"/>
       </a:lnSpc>
@@ -219,7 +219,7 @@
         <a:sym typeface="Helvetica Neue"/>
       </a:defRPr>
     </a:lvl6pPr>
-    <a:lvl7pPr marL="0" marR="0" indent="2743200" algn="l" defTabSz="2438338" rtl="0" fontAlgn="auto" latinLnBrk="0" hangingPunct="0">
+    <a:lvl7pPr marL="0" marR="0" indent="0" algn="l" defTabSz="2438337" rtl="0" fontAlgn="auto" latinLnBrk="0" hangingPunct="0">
       <a:lnSpc>
         <a:spcPct val="90000"/>
       </a:lnSpc>
@@ -249,7 +249,7 @@
         <a:sym typeface="Helvetica Neue"/>
       </a:defRPr>
     </a:lvl7pPr>
-    <a:lvl8pPr marL="0" marR="0" indent="3200400" algn="l" defTabSz="2438338" rtl="0" fontAlgn="auto" latinLnBrk="0" hangingPunct="0">
+    <a:lvl8pPr marL="0" marR="0" indent="0" algn="l" defTabSz="2438337" rtl="0" fontAlgn="auto" latinLnBrk="0" hangingPunct="0">
       <a:lnSpc>
         <a:spcPct val="90000"/>
       </a:lnSpc>
@@ -279,7 +279,7 @@
         <a:sym typeface="Helvetica Neue"/>
       </a:defRPr>
     </a:lvl8pPr>
-    <a:lvl9pPr marL="0" marR="0" indent="3657600" algn="l" defTabSz="2438338" rtl="0" fontAlgn="auto" latinLnBrk="0" hangingPunct="0">
+    <a:lvl9pPr marL="0" marR="0" indent="0" algn="l" defTabSz="2438337" rtl="0" fontAlgn="auto" latinLnBrk="0" hangingPunct="0">
       <a:lnSpc>
         <a:spcPct val="90000"/>
       </a:lnSpc>
@@ -492,7 +492,7 @@
 </file>
 
 <file path=ppt/slideLayouts/slideLayout1.xml><?xml version="1.0" encoding="utf-8"?>
-<p:sldLayout xmlns:a="http://schemas.openxmlformats.org/drawingml/2006/main" xmlns:r="http://schemas.openxmlformats.org/officeDocument/2006/relationships" xmlns:p="http://schemas.openxmlformats.org/presentationml/2006/main" xmlns:m="http://schemas.openxmlformats.org/officeDocument/2006/math" xmlns:a14="http://schemas.microsoft.com/office/drawing/2010/main" type="title" showMasterSp="1" showMasterPhAnim="1">
+<p:sldLayout xmlns:a="http://schemas.openxmlformats.org/drawingml/2006/main" xmlns:r="http://schemas.openxmlformats.org/officeDocument/2006/relationships" xmlns:p="http://schemas.openxmlformats.org/presentationml/2006/main" xmlns:m="http://schemas.openxmlformats.org/officeDocument/2006/math" xmlns:a14="http://schemas.microsoft.com/office/drawing/2010/main" type="tx" showMasterSp="1" showMasterPhAnim="1">
   <p:cSld name="标题">
     <p:spTree>
       <p:nvGrpSpPr>
@@ -510,23 +510,23 @@
       </p:grpSpPr>
       <p:sp>
         <p:nvSpPr>
-          <p:cNvPr id="11" name="作者和日期"/>
+          <p:cNvPr id="11" name="正文级别 1…"/>
           <p:cNvSpPr txBox="1"/>
           <p:nvPr>
-            <p:ph type="body" sz="quarter" idx="21" hasCustomPrompt="1"/>
+            <p:ph type="body" sz="quarter" idx="1" hasCustomPrompt="1"/>
           </p:nvPr>
         </p:nvSpPr>
         <p:spPr>
           <a:xfrm>
             <a:off x="1201340" y="11859862"/>
-            <a:ext cx="21971003" cy="636979"/>
+            <a:ext cx="21971004" cy="636980"/>
           </a:xfrm>
           <a:prstGeom prst="rect">
             <a:avLst/>
           </a:prstGeom>
         </p:spPr>
         <p:txBody>
-          <a:bodyPr lIns="45719" tIns="45719" rIns="45719" bIns="45719"/>
+          <a:bodyPr lIns="45718" tIns="45718" rIns="45718" bIns="45718" numCol="1" spcCol="38100"/>
           <a:lstStyle>
             <a:lvl1pPr marL="0" indent="0" defTabSz="701675">
               <a:lnSpc>
@@ -537,13 +537,73 @@
               </a:spcBef>
               <a:buSzTx/>
               <a:buNone/>
-              <a:defRPr b="1" sz="3060"/>
+              <a:defRPr b="1" sz="3000"/>
             </a:lvl1pPr>
+            <a:lvl2pPr marL="990600" indent="-381000" defTabSz="701675">
+              <a:lnSpc>
+                <a:spcPct val="100000"/>
+              </a:lnSpc>
+              <a:spcBef>
+                <a:spcPts val="0"/>
+              </a:spcBef>
+              <a:defRPr b="1" sz="3000"/>
+            </a:lvl2pPr>
+            <a:lvl3pPr marL="1600200" indent="-381000" defTabSz="701675">
+              <a:lnSpc>
+                <a:spcPct val="100000"/>
+              </a:lnSpc>
+              <a:spcBef>
+                <a:spcPts val="0"/>
+              </a:spcBef>
+              <a:defRPr b="1" sz="3000"/>
+            </a:lvl3pPr>
+            <a:lvl4pPr marL="2209800" indent="-381000" defTabSz="701675">
+              <a:lnSpc>
+                <a:spcPct val="100000"/>
+              </a:lnSpc>
+              <a:spcBef>
+                <a:spcPts val="0"/>
+              </a:spcBef>
+              <a:defRPr b="1" sz="3000"/>
+            </a:lvl4pPr>
+            <a:lvl5pPr marL="2819400" indent="-381000" defTabSz="701675">
+              <a:lnSpc>
+                <a:spcPct val="100000"/>
+              </a:lnSpc>
+              <a:spcBef>
+                <a:spcPts val="0"/>
+              </a:spcBef>
+              <a:defRPr b="1" sz="3000"/>
+            </a:lvl5pPr>
           </a:lstStyle>
           <a:p>
             <a:pPr/>
             <a:r>
               <a:t>作者和日期</a:t>
+            </a:r>
+          </a:p>
+          <a:p>
+            <a:pPr lvl="1"/>
+            <a:r>
+              <a:t/>
+            </a:r>
+          </a:p>
+          <a:p>
+            <a:pPr lvl="2"/>
+            <a:r>
+              <a:t/>
+            </a:r>
+          </a:p>
+          <a:p>
+            <a:pPr lvl="3"/>
+            <a:r>
+              <a:t/>
+            </a:r>
+          </a:p>
+          <a:p>
+            <a:pPr lvl="4"/>
+            <a:r>
+              <a:t/>
             </a:r>
           </a:p>
         </p:txBody>
@@ -559,7 +619,7 @@
         <p:spPr>
           <a:xfrm>
             <a:off x="1206496" y="2574991"/>
-            <a:ext cx="21971004" cy="4648201"/>
+            <a:ext cx="21971005" cy="4648202"/>
           </a:xfrm>
           <a:prstGeom prst="rect">
             <a:avLst/>
@@ -585,20 +645,20 @@
           <p:cNvPr id="13" name="正文级别 1…"/>
           <p:cNvSpPr txBox="1"/>
           <p:nvPr>
-            <p:ph type="body" sz="quarter" idx="1" hasCustomPrompt="1"/>
+            <p:ph type="body" sz="quarter" idx="21" hasCustomPrompt="1"/>
           </p:nvPr>
         </p:nvSpPr>
         <p:spPr>
           <a:xfrm>
             <a:off x="1201342" y="7223190"/>
-            <a:ext cx="21971001" cy="1905001"/>
+            <a:ext cx="21971002" cy="1905002"/>
           </a:xfrm>
           <a:prstGeom prst="rect">
             <a:avLst/>
           </a:prstGeom>
         </p:spPr>
         <p:txBody>
-          <a:bodyPr/>
+          <a:bodyPr numCol="1" spcCol="38100"/>
           <a:lstStyle>
             <a:lvl1pPr marL="0" indent="0" defTabSz="825500">
               <a:lnSpc>
@@ -611,79 +671,11 @@
               <a:buNone/>
               <a:defRPr b="1" sz="5500"/>
             </a:lvl1pPr>
-            <a:lvl2pPr marL="0" indent="457200" defTabSz="825500">
-              <a:lnSpc>
-                <a:spcPct val="100000"/>
-              </a:lnSpc>
-              <a:spcBef>
-                <a:spcPts val="0"/>
-              </a:spcBef>
-              <a:buSzTx/>
-              <a:buNone/>
-              <a:defRPr b="1" sz="5500"/>
-            </a:lvl2pPr>
-            <a:lvl3pPr marL="0" indent="914400" defTabSz="825500">
-              <a:lnSpc>
-                <a:spcPct val="100000"/>
-              </a:lnSpc>
-              <a:spcBef>
-                <a:spcPts val="0"/>
-              </a:spcBef>
-              <a:buSzTx/>
-              <a:buNone/>
-              <a:defRPr b="1" sz="5500"/>
-            </a:lvl3pPr>
-            <a:lvl4pPr marL="0" indent="1371600" defTabSz="825500">
-              <a:lnSpc>
-                <a:spcPct val="100000"/>
-              </a:lnSpc>
-              <a:spcBef>
-                <a:spcPts val="0"/>
-              </a:spcBef>
-              <a:buSzTx/>
-              <a:buNone/>
-              <a:defRPr b="1" sz="5500"/>
-            </a:lvl4pPr>
-            <a:lvl5pPr marL="0" indent="1828800" defTabSz="825500">
-              <a:lnSpc>
-                <a:spcPct val="100000"/>
-              </a:lnSpc>
-              <a:spcBef>
-                <a:spcPts val="0"/>
-              </a:spcBef>
-              <a:buSzTx/>
-              <a:buNone/>
-              <a:defRPr b="1" sz="5500"/>
-            </a:lvl5pPr>
           </a:lstStyle>
           <a:p>
             <a:pPr/>
             <a:r>
               <a:t>演示文稿副标题</a:t>
-            </a:r>
-          </a:p>
-          <a:p>
-            <a:pPr lvl="1"/>
-            <a:r>
-              <a:t/>
-            </a:r>
-          </a:p>
-          <a:p>
-            <a:pPr lvl="2"/>
-            <a:r>
-              <a:t/>
-            </a:r>
-          </a:p>
-          <a:p>
-            <a:pPr lvl="3"/>
-            <a:r>
-              <a:t/>
-            </a:r>
-          </a:p>
-          <a:p>
-            <a:pPr lvl="4"/>
-            <a:r>
-              <a:t/>
             </a:r>
           </a:p>
         </p:txBody>
@@ -747,7 +739,7 @@
         <p:spPr>
           <a:xfrm>
             <a:off x="1206500" y="1079500"/>
-            <a:ext cx="21971000" cy="1434949"/>
+            <a:ext cx="21971000" cy="1434950"/>
           </a:xfrm>
           <a:prstGeom prst="rect">
             <a:avLst/>
@@ -766,23 +758,23 @@
       </p:sp>
       <p:sp>
         <p:nvSpPr>
-          <p:cNvPr id="100" name="幻灯片副标题"/>
+          <p:cNvPr id="100" name="正文级别 1…"/>
           <p:cNvSpPr txBox="1"/>
           <p:nvPr>
-            <p:ph type="body" sz="quarter" idx="21" hasCustomPrompt="1"/>
+            <p:ph type="body" sz="quarter" idx="1" hasCustomPrompt="1"/>
           </p:nvPr>
         </p:nvSpPr>
         <p:spPr>
           <a:xfrm>
-            <a:off x="1206500" y="2372962"/>
-            <a:ext cx="21971000" cy="934780"/>
+            <a:off x="1206500" y="2372961"/>
+            <a:ext cx="21971000" cy="934781"/>
           </a:xfrm>
           <a:prstGeom prst="rect">
             <a:avLst/>
           </a:prstGeom>
         </p:spPr>
         <p:txBody>
-          <a:bodyPr lIns="45719" tIns="45719" rIns="45719" bIns="45719"/>
+          <a:bodyPr lIns="45718" tIns="45718" rIns="45718" bIns="45718" numCol="1" spcCol="38100"/>
           <a:lstStyle>
             <a:lvl1pPr marL="0" indent="0" defTabSz="726440">
               <a:lnSpc>
@@ -793,13 +785,73 @@
               </a:spcBef>
               <a:buSzTx/>
               <a:buNone/>
-              <a:defRPr b="1" sz="4840"/>
+              <a:defRPr b="1"/>
             </a:lvl1pPr>
+            <a:lvl2pPr defTabSz="726440">
+              <a:lnSpc>
+                <a:spcPct val="100000"/>
+              </a:lnSpc>
+              <a:spcBef>
+                <a:spcPts val="0"/>
+              </a:spcBef>
+              <a:defRPr b="1"/>
+            </a:lvl2pPr>
+            <a:lvl3pPr defTabSz="726440">
+              <a:lnSpc>
+                <a:spcPct val="100000"/>
+              </a:lnSpc>
+              <a:spcBef>
+                <a:spcPts val="0"/>
+              </a:spcBef>
+              <a:defRPr b="1"/>
+            </a:lvl3pPr>
+            <a:lvl4pPr defTabSz="726440">
+              <a:lnSpc>
+                <a:spcPct val="100000"/>
+              </a:lnSpc>
+              <a:spcBef>
+                <a:spcPts val="0"/>
+              </a:spcBef>
+              <a:defRPr b="1"/>
+            </a:lvl4pPr>
+            <a:lvl5pPr defTabSz="726440">
+              <a:lnSpc>
+                <a:spcPct val="100000"/>
+              </a:lnSpc>
+              <a:spcBef>
+                <a:spcPts val="0"/>
+              </a:spcBef>
+              <a:defRPr b="1"/>
+            </a:lvl5pPr>
           </a:lstStyle>
           <a:p>
             <a:pPr/>
             <a:r>
               <a:t>幻灯片副标题</a:t>
+            </a:r>
+          </a:p>
+          <a:p>
+            <a:pPr lvl="1"/>
+            <a:r>
+              <a:t/>
+            </a:r>
+          </a:p>
+          <a:p>
+            <a:pPr lvl="2"/>
+            <a:r>
+              <a:t/>
+            </a:r>
+          </a:p>
+          <a:p>
+            <a:pPr lvl="3"/>
+            <a:r>
+              <a:t/>
+            </a:r>
+          </a:p>
+          <a:p>
+            <a:pPr lvl="4"/>
+            <a:r>
+              <a:t/>
             </a:r>
           </a:p>
         </p:txBody>
@@ -882,23 +934,23 @@
       </p:sp>
       <p:sp>
         <p:nvSpPr>
-          <p:cNvPr id="109" name="议程副标题"/>
+          <p:cNvPr id="109" name="正文级别 1…"/>
           <p:cNvSpPr txBox="1"/>
           <p:nvPr>
-            <p:ph type="body" sz="quarter" idx="21" hasCustomPrompt="1"/>
+            <p:ph type="body" sz="quarter" idx="1" hasCustomPrompt="1"/>
           </p:nvPr>
         </p:nvSpPr>
         <p:spPr>
           <a:xfrm>
-            <a:off x="1206500" y="2372962"/>
-            <a:ext cx="21971000" cy="934780"/>
+            <a:off x="1206500" y="2372961"/>
+            <a:ext cx="21971000" cy="934781"/>
           </a:xfrm>
           <a:prstGeom prst="rect">
             <a:avLst/>
           </a:prstGeom>
         </p:spPr>
         <p:txBody>
-          <a:bodyPr lIns="45719" tIns="45719" rIns="45719" bIns="45719"/>
+          <a:bodyPr lIns="45718" tIns="45718" rIns="45718" bIns="45718" numCol="1" spcCol="38100"/>
           <a:lstStyle>
             <a:lvl1pPr marL="0" indent="0" defTabSz="726440">
               <a:lnSpc>
@@ -909,13 +961,73 @@
               </a:spcBef>
               <a:buSzTx/>
               <a:buNone/>
-              <a:defRPr b="1" sz="4840"/>
+              <a:defRPr b="1"/>
             </a:lvl1pPr>
+            <a:lvl2pPr defTabSz="726440">
+              <a:lnSpc>
+                <a:spcPct val="100000"/>
+              </a:lnSpc>
+              <a:spcBef>
+                <a:spcPts val="0"/>
+              </a:spcBef>
+              <a:defRPr b="1"/>
+            </a:lvl2pPr>
+            <a:lvl3pPr defTabSz="726440">
+              <a:lnSpc>
+                <a:spcPct val="100000"/>
+              </a:lnSpc>
+              <a:spcBef>
+                <a:spcPts val="0"/>
+              </a:spcBef>
+              <a:defRPr b="1"/>
+            </a:lvl3pPr>
+            <a:lvl4pPr defTabSz="726440">
+              <a:lnSpc>
+                <a:spcPct val="100000"/>
+              </a:lnSpc>
+              <a:spcBef>
+                <a:spcPts val="0"/>
+              </a:spcBef>
+              <a:defRPr b="1"/>
+            </a:lvl4pPr>
+            <a:lvl5pPr defTabSz="726440">
+              <a:lnSpc>
+                <a:spcPct val="100000"/>
+              </a:lnSpc>
+              <a:spcBef>
+                <a:spcPts val="0"/>
+              </a:spcBef>
+              <a:defRPr b="1"/>
+            </a:lvl5pPr>
           </a:lstStyle>
           <a:p>
             <a:pPr/>
             <a:r>
               <a:t>议程副标题</a:t>
+            </a:r>
+          </a:p>
+          <a:p>
+            <a:pPr lvl="1"/>
+            <a:r>
+              <a:t/>
+            </a:r>
+          </a:p>
+          <a:p>
+            <a:pPr lvl="2"/>
+            <a:r>
+              <a:t/>
+            </a:r>
+          </a:p>
+          <a:p>
+            <a:pPr lvl="3"/>
+            <a:r>
+              <a:t/>
+            </a:r>
+          </a:p>
+          <a:p>
+            <a:pPr lvl="4"/>
+            <a:r>
+              <a:t/>
             </a:r>
           </a:p>
         </p:txBody>
@@ -925,16 +1037,20 @@
           <p:cNvPr id="110" name="正文级别 1…"/>
           <p:cNvSpPr txBox="1"/>
           <p:nvPr>
-            <p:ph type="body" idx="1" hasCustomPrompt="1"/>
+            <p:ph type="body" idx="21" hasCustomPrompt="1"/>
           </p:nvPr>
         </p:nvSpPr>
         <p:spPr>
+          <a:xfrm>
+            <a:off x="1206500" y="4248503"/>
+            <a:ext cx="21971000" cy="8256014"/>
+          </a:xfrm>
           <a:prstGeom prst="rect">
             <a:avLst/>
           </a:prstGeom>
         </p:spPr>
         <p:txBody>
-          <a:bodyPr/>
+          <a:bodyPr numCol="1" spcCol="38100"/>
           <a:lstStyle>
             <a:lvl1pPr marL="0" indent="0" defTabSz="825500">
               <a:lnSpc>
@@ -945,81 +1061,13 @@
               </a:spcBef>
               <a:buSzTx/>
               <a:buNone/>
-              <a:defRPr spc="-55" sz="5500"/>
+              <a:defRPr spc="-99" sz="5500"/>
             </a:lvl1pPr>
-            <a:lvl2pPr marL="0" indent="457200" defTabSz="825500">
-              <a:lnSpc>
-                <a:spcPct val="100000"/>
-              </a:lnSpc>
-              <a:spcBef>
-                <a:spcPts val="1800"/>
-              </a:spcBef>
-              <a:buSzTx/>
-              <a:buNone/>
-              <a:defRPr spc="-55" sz="5500"/>
-            </a:lvl2pPr>
-            <a:lvl3pPr marL="0" indent="914400" defTabSz="825500">
-              <a:lnSpc>
-                <a:spcPct val="100000"/>
-              </a:lnSpc>
-              <a:spcBef>
-                <a:spcPts val="1800"/>
-              </a:spcBef>
-              <a:buSzTx/>
-              <a:buNone/>
-              <a:defRPr spc="-55" sz="5500"/>
-            </a:lvl3pPr>
-            <a:lvl4pPr marL="0" indent="1371600" defTabSz="825500">
-              <a:lnSpc>
-                <a:spcPct val="100000"/>
-              </a:lnSpc>
-              <a:spcBef>
-                <a:spcPts val="1800"/>
-              </a:spcBef>
-              <a:buSzTx/>
-              <a:buNone/>
-              <a:defRPr spc="-55" sz="5500"/>
-            </a:lvl4pPr>
-            <a:lvl5pPr marL="0" indent="1828800" defTabSz="825500">
-              <a:lnSpc>
-                <a:spcPct val="100000"/>
-              </a:lnSpc>
-              <a:spcBef>
-                <a:spcPts val="1800"/>
-              </a:spcBef>
-              <a:buSzTx/>
-              <a:buNone/>
-              <a:defRPr spc="-55" sz="5500"/>
-            </a:lvl5pPr>
           </a:lstStyle>
           <a:p>
             <a:pPr/>
             <a:r>
               <a:t>议程主题</a:t>
-            </a:r>
-          </a:p>
-          <a:p>
-            <a:pPr lvl="1"/>
-            <a:r>
-              <a:t/>
-            </a:r>
-          </a:p>
-          <a:p>
-            <a:pPr lvl="2"/>
-            <a:r>
-              <a:t/>
-            </a:r>
-          </a:p>
-          <a:p>
-            <a:pPr lvl="3"/>
-            <a:r>
-              <a:t/>
-            </a:r>
-          </a:p>
-          <a:p>
-            <a:pPr lvl="4"/>
-            <a:r>
-              <a:t/>
             </a:r>
           </a:p>
         </p:txBody>
@@ -1090,7 +1138,7 @@
           </a:prstGeom>
         </p:spPr>
         <p:txBody>
-          <a:bodyPr anchor="ctr"/>
+          <a:bodyPr numCol="1" spcCol="38100" anchor="ctr"/>
           <a:lstStyle>
             <a:lvl1pPr marL="0" indent="0" algn="ctr">
               <a:lnSpc>
@@ -1108,7 +1156,7 @@
                 <a:sym typeface="Helvetica Neue Medium"/>
               </a:defRPr>
             </a:lvl1pPr>
-            <a:lvl2pPr marL="0" indent="457200" algn="ctr">
+            <a:lvl2pPr marL="0" indent="0" algn="ctr">
               <a:lnSpc>
                 <a:spcPct val="80000"/>
               </a:lnSpc>
@@ -1124,7 +1172,7 @@
                 <a:sym typeface="Helvetica Neue Medium"/>
               </a:defRPr>
             </a:lvl2pPr>
-            <a:lvl3pPr marL="0" indent="914400" algn="ctr">
+            <a:lvl3pPr marL="0" indent="0" algn="ctr">
               <a:lnSpc>
                 <a:spcPct val="80000"/>
               </a:lnSpc>
@@ -1140,7 +1188,7 @@
                 <a:sym typeface="Helvetica Neue Medium"/>
               </a:defRPr>
             </a:lvl3pPr>
-            <a:lvl4pPr marL="0" indent="1371600" algn="ctr">
+            <a:lvl4pPr marL="0" indent="0" algn="ctr">
               <a:lnSpc>
                 <a:spcPct val="80000"/>
               </a:lnSpc>
@@ -1156,7 +1204,7 @@
                 <a:sym typeface="Helvetica Neue Medium"/>
               </a:defRPr>
             </a:lvl4pPr>
-            <a:lvl5pPr marL="0" indent="1828800" algn="ctr">
+            <a:lvl5pPr marL="0" indent="0" algn="ctr">
               <a:lnSpc>
                 <a:spcPct val="80000"/>
               </a:lnSpc>
@@ -1263,15 +1311,15 @@
         </p:nvSpPr>
         <p:spPr>
           <a:xfrm>
-            <a:off x="1206500" y="1075927"/>
-            <a:ext cx="21971000" cy="7241584"/>
+            <a:off x="1206500" y="1075926"/>
+            <a:ext cx="21971000" cy="7241586"/>
           </a:xfrm>
           <a:prstGeom prst="rect">
             <a:avLst/>
           </a:prstGeom>
         </p:spPr>
         <p:txBody>
-          <a:bodyPr anchor="b"/>
+          <a:bodyPr numCol="1" spcCol="38100" anchor="b"/>
           <a:lstStyle>
             <a:lvl1pPr marL="0" indent="0" algn="ctr">
               <a:lnSpc>
@@ -1284,7 +1332,7 @@
               <a:buNone/>
               <a:defRPr b="1" spc="-250" sz="25000"/>
             </a:lvl1pPr>
-            <a:lvl2pPr marL="0" indent="457200" algn="ctr">
+            <a:lvl2pPr marL="0" indent="0" algn="ctr">
               <a:lnSpc>
                 <a:spcPct val="80000"/>
               </a:lnSpc>
@@ -1295,7 +1343,7 @@
               <a:buNone/>
               <a:defRPr b="1" spc="-250" sz="25000"/>
             </a:lvl2pPr>
-            <a:lvl3pPr marL="0" indent="914400" algn="ctr">
+            <a:lvl3pPr marL="0" indent="0" algn="ctr">
               <a:lnSpc>
                 <a:spcPct val="80000"/>
               </a:lnSpc>
@@ -1306,7 +1354,7 @@
               <a:buNone/>
               <a:defRPr b="1" spc="-250" sz="25000"/>
             </a:lvl3pPr>
-            <a:lvl4pPr marL="0" indent="1371600" algn="ctr">
+            <a:lvl4pPr marL="0" indent="0" algn="ctr">
               <a:lnSpc>
                 <a:spcPct val="80000"/>
               </a:lnSpc>
@@ -1317,7 +1365,7 @@
               <a:buNone/>
               <a:defRPr b="1" spc="-250" sz="25000"/>
             </a:lvl4pPr>
-            <a:lvl5pPr marL="0" indent="1828800" algn="ctr">
+            <a:lvl5pPr marL="0" indent="0" algn="ctr">
               <a:lnSpc>
                 <a:spcPct val="80000"/>
               </a:lnSpc>
@@ -1379,7 +1427,7 @@
           </a:prstGeom>
         </p:spPr>
         <p:txBody>
-          <a:bodyPr lIns="45719" tIns="45719" rIns="45719" bIns="45719"/>
+          <a:bodyPr lIns="45718" tIns="45718" rIns="45718" bIns="45718" numCol="1" spcCol="38100"/>
           <a:lstStyle>
             <a:lvl1pPr marL="0" indent="0" algn="ctr" defTabSz="726440">
               <a:lnSpc>
@@ -1390,7 +1438,7 @@
               </a:spcBef>
               <a:buSzTx/>
               <a:buNone/>
-              <a:defRPr b="1" sz="4840"/>
+              <a:defRPr b="1"/>
             </a:lvl1pPr>
           </a:lstStyle>
           <a:p>
@@ -1451,23 +1499,23 @@
       </p:grpSpPr>
       <p:sp>
         <p:nvSpPr>
-          <p:cNvPr id="135" name="出自"/>
+          <p:cNvPr id="135" name="正文级别 1…"/>
           <p:cNvSpPr txBox="1"/>
           <p:nvPr>
-            <p:ph type="body" sz="quarter" idx="21" hasCustomPrompt="1"/>
+            <p:ph type="body" sz="quarter" idx="1" hasCustomPrompt="1"/>
           </p:nvPr>
         </p:nvSpPr>
         <p:spPr>
           <a:xfrm>
-            <a:off x="2430025" y="10675453"/>
-            <a:ext cx="20200052" cy="636979"/>
+            <a:off x="2430024" y="10675453"/>
+            <a:ext cx="20200054" cy="636980"/>
           </a:xfrm>
           <a:prstGeom prst="rect">
             <a:avLst/>
           </a:prstGeom>
         </p:spPr>
         <p:txBody>
-          <a:bodyPr lIns="45719" tIns="45719" rIns="45719" bIns="45719"/>
+          <a:bodyPr lIns="45718" tIns="45718" rIns="45718" bIns="45718" numCol="1" spcCol="38100"/>
           <a:lstStyle>
             <a:lvl1pPr marL="0" indent="0" defTabSz="701675">
               <a:lnSpc>
@@ -1478,13 +1526,73 @@
               </a:spcBef>
               <a:buSzTx/>
               <a:buNone/>
-              <a:defRPr b="1" sz="3060"/>
+              <a:defRPr b="1" sz="3000"/>
             </a:lvl1pPr>
+            <a:lvl2pPr marL="990600" indent="-381000" defTabSz="701675">
+              <a:lnSpc>
+                <a:spcPct val="100000"/>
+              </a:lnSpc>
+              <a:spcBef>
+                <a:spcPts val="0"/>
+              </a:spcBef>
+              <a:defRPr b="1" sz="3000"/>
+            </a:lvl2pPr>
+            <a:lvl3pPr marL="1600200" indent="-381000" defTabSz="701675">
+              <a:lnSpc>
+                <a:spcPct val="100000"/>
+              </a:lnSpc>
+              <a:spcBef>
+                <a:spcPts val="0"/>
+              </a:spcBef>
+              <a:defRPr b="1" sz="3000"/>
+            </a:lvl3pPr>
+            <a:lvl4pPr marL="2209800" indent="-381000" defTabSz="701675">
+              <a:lnSpc>
+                <a:spcPct val="100000"/>
+              </a:lnSpc>
+              <a:spcBef>
+                <a:spcPts val="0"/>
+              </a:spcBef>
+              <a:defRPr b="1" sz="3000"/>
+            </a:lvl4pPr>
+            <a:lvl5pPr marL="2819400" indent="-381000" defTabSz="701675">
+              <a:lnSpc>
+                <a:spcPct val="100000"/>
+              </a:lnSpc>
+              <a:spcBef>
+                <a:spcPts val="0"/>
+              </a:spcBef>
+              <a:defRPr b="1" sz="3000"/>
+            </a:lvl5pPr>
           </a:lstStyle>
           <a:p>
             <a:pPr/>
             <a:r>
               <a:t>出自</a:t>
+            </a:r>
+          </a:p>
+          <a:p>
+            <a:pPr lvl="1"/>
+            <a:r>
+              <a:t/>
+            </a:r>
+          </a:p>
+          <a:p>
+            <a:pPr lvl="2"/>
+            <a:r>
+              <a:t/>
+            </a:r>
+          </a:p>
+          <a:p>
+            <a:pPr lvl="3"/>
+            <a:r>
+              <a:t/>
+            </a:r>
+          </a:p>
+          <a:p>
+            <a:pPr lvl="4"/>
+            <a:r>
+              <a:t/>
             </a:r>
           </a:p>
         </p:txBody>
@@ -1494,115 +1602,39 @@
           <p:cNvPr id="136" name="正文级别 1…"/>
           <p:cNvSpPr txBox="1"/>
           <p:nvPr>
-            <p:ph type="body" sz="half" idx="1" hasCustomPrompt="1"/>
+            <p:ph type="body" sz="half" idx="21" hasCustomPrompt="1"/>
           </p:nvPr>
         </p:nvSpPr>
         <p:spPr>
           <a:xfrm>
             <a:off x="1753923" y="4939860"/>
-            <a:ext cx="20876154" cy="3836280"/>
+            <a:ext cx="20876154" cy="3836281"/>
           </a:xfrm>
           <a:prstGeom prst="rect">
             <a:avLst/>
           </a:prstGeom>
         </p:spPr>
         <p:txBody>
-          <a:bodyPr/>
+          <a:bodyPr numCol="1" spcCol="38100"/>
           <a:lstStyle>
-            <a:lvl1pPr marL="638923" indent="-469900">
+            <a:lvl1pPr marL="469900" indent="-300876">
               <a:spcBef>
                 <a:spcPts val="0"/>
               </a:spcBef>
               <a:buSzTx/>
               <a:buNone/>
-              <a:defRPr spc="-170" sz="8500">
+              <a:defRPr spc="-200" sz="8500">
                 <a:latin typeface="Helvetica Neue Medium"/>
                 <a:ea typeface="Helvetica Neue Medium"/>
                 <a:cs typeface="Helvetica Neue Medium"/>
                 <a:sym typeface="Helvetica Neue Medium"/>
               </a:defRPr>
             </a:lvl1pPr>
-            <a:lvl2pPr marL="638923" indent="-12700">
-              <a:spcBef>
-                <a:spcPts val="0"/>
-              </a:spcBef>
-              <a:buSzTx/>
-              <a:buNone/>
-              <a:defRPr spc="-170" sz="8500">
-                <a:latin typeface="Helvetica Neue Medium"/>
-                <a:ea typeface="Helvetica Neue Medium"/>
-                <a:cs typeface="Helvetica Neue Medium"/>
-                <a:sym typeface="Helvetica Neue Medium"/>
-              </a:defRPr>
-            </a:lvl2pPr>
-            <a:lvl3pPr marL="638923" indent="444500">
-              <a:spcBef>
-                <a:spcPts val="0"/>
-              </a:spcBef>
-              <a:buSzTx/>
-              <a:buNone/>
-              <a:defRPr spc="-170" sz="8500">
-                <a:latin typeface="Helvetica Neue Medium"/>
-                <a:ea typeface="Helvetica Neue Medium"/>
-                <a:cs typeface="Helvetica Neue Medium"/>
-                <a:sym typeface="Helvetica Neue Medium"/>
-              </a:defRPr>
-            </a:lvl3pPr>
-            <a:lvl4pPr marL="638923" indent="901700">
-              <a:spcBef>
-                <a:spcPts val="0"/>
-              </a:spcBef>
-              <a:buSzTx/>
-              <a:buNone/>
-              <a:defRPr spc="-170" sz="8500">
-                <a:latin typeface="Helvetica Neue Medium"/>
-                <a:ea typeface="Helvetica Neue Medium"/>
-                <a:cs typeface="Helvetica Neue Medium"/>
-                <a:sym typeface="Helvetica Neue Medium"/>
-              </a:defRPr>
-            </a:lvl4pPr>
-            <a:lvl5pPr marL="638923" indent="1358900">
-              <a:spcBef>
-                <a:spcPts val="0"/>
-              </a:spcBef>
-              <a:buSzTx/>
-              <a:buNone/>
-              <a:defRPr spc="-170" sz="8500">
-                <a:latin typeface="Helvetica Neue Medium"/>
-                <a:ea typeface="Helvetica Neue Medium"/>
-                <a:cs typeface="Helvetica Neue Medium"/>
-                <a:sym typeface="Helvetica Neue Medium"/>
-              </a:defRPr>
-            </a:lvl5pPr>
           </a:lstStyle>
           <a:p>
             <a:pPr/>
             <a:r>
               <a:t>“著名引文”</a:t>
-            </a:r>
-          </a:p>
-          <a:p>
-            <a:pPr lvl="1"/>
-            <a:r>
-              <a:t/>
-            </a:r>
-          </a:p>
-          <a:p>
-            <a:pPr lvl="2"/>
-            <a:r>
-              <a:t/>
-            </a:r>
-          </a:p>
-          <a:p>
-            <a:pPr lvl="3"/>
-            <a:r>
-              <a:t/>
-            </a:r>
-          </a:p>
-          <a:p>
-            <a:pPr lvl="4"/>
-            <a:r>
-              <a:t/>
             </a:r>
           </a:p>
         </p:txBody>
@@ -1673,7 +1705,7 @@
           </a:prstGeom>
         </p:spPr>
         <p:txBody>
-          <a:bodyPr lIns="91439" tIns="45719" rIns="91439" bIns="45719">
+          <a:bodyPr lIns="91439" tIns="45719" rIns="91439" bIns="45719" numCol="1" spcCol="38100">
             <a:noAutofit/>
           </a:bodyPr>
           <a:lstStyle/>
@@ -1700,7 +1732,7 @@
           </a:prstGeom>
         </p:spPr>
         <p:txBody>
-          <a:bodyPr lIns="91439" tIns="45719" rIns="91439" bIns="45719">
+          <a:bodyPr lIns="91439" tIns="45719" rIns="91439" bIns="45719" numCol="1" spcCol="38100">
             <a:noAutofit/>
           </a:bodyPr>
           <a:lstStyle/>
@@ -1727,7 +1759,7 @@
           </a:prstGeom>
         </p:spPr>
         <p:txBody>
-          <a:bodyPr lIns="91439" tIns="45719" rIns="91439" bIns="45719">
+          <a:bodyPr lIns="91439" tIns="45719" rIns="91439" bIns="45719" numCol="1" spcCol="38100">
             <a:noAutofit/>
           </a:bodyPr>
           <a:lstStyle/>
@@ -1802,7 +1834,7 @@
           </a:prstGeom>
         </p:spPr>
         <p:txBody>
-          <a:bodyPr lIns="91439" tIns="45719" rIns="91439" bIns="45719">
+          <a:bodyPr lIns="91439" tIns="45719" rIns="91439" bIns="45719" numCol="1" spcCol="38100">
             <a:noAutofit/>
           </a:bodyPr>
           <a:lstStyle/>
@@ -1933,7 +1965,7 @@
           </a:prstGeom>
         </p:spPr>
         <p:txBody>
-          <a:bodyPr lIns="91439" tIns="45719" rIns="91439" bIns="45719">
+          <a:bodyPr lIns="91439" tIns="45719" rIns="91439" bIns="45719" numCol="1" spcCol="38100">
             <a:noAutofit/>
           </a:bodyPr>
           <a:lstStyle/>
@@ -1976,23 +2008,23 @@
       </p:sp>
       <p:sp>
         <p:nvSpPr>
-          <p:cNvPr id="23" name="作者和日期"/>
+          <p:cNvPr id="23" name="正文级别 1…"/>
           <p:cNvSpPr txBox="1"/>
           <p:nvPr>
-            <p:ph type="body" sz="quarter" idx="22" hasCustomPrompt="1"/>
+            <p:ph type="body" sz="quarter" idx="1" hasCustomPrompt="1"/>
           </p:nvPr>
         </p:nvSpPr>
         <p:spPr>
           <a:xfrm>
             <a:off x="1207690" y="1106137"/>
-            <a:ext cx="21968621" cy="636979"/>
+            <a:ext cx="21968621" cy="636980"/>
           </a:xfrm>
           <a:prstGeom prst="rect">
             <a:avLst/>
           </a:prstGeom>
         </p:spPr>
         <p:txBody>
-          <a:bodyPr lIns="45719" tIns="45719" rIns="45719" bIns="45719"/>
+          <a:bodyPr lIns="45718" tIns="45718" rIns="45718" bIns="45718" numCol="1" spcCol="38100"/>
           <a:lstStyle>
             <a:lvl1pPr marL="0" indent="0" defTabSz="701675">
               <a:lnSpc>
@@ -2003,13 +2035,73 @@
               </a:spcBef>
               <a:buSzTx/>
               <a:buNone/>
-              <a:defRPr b="1" sz="3060"/>
+              <a:defRPr b="1" sz="3000"/>
             </a:lvl1pPr>
+            <a:lvl2pPr marL="990600" indent="-381000" defTabSz="701675">
+              <a:lnSpc>
+                <a:spcPct val="100000"/>
+              </a:lnSpc>
+              <a:spcBef>
+                <a:spcPts val="0"/>
+              </a:spcBef>
+              <a:defRPr b="1" sz="3000"/>
+            </a:lvl2pPr>
+            <a:lvl3pPr marL="1600200" indent="-381000" defTabSz="701675">
+              <a:lnSpc>
+                <a:spcPct val="100000"/>
+              </a:lnSpc>
+              <a:spcBef>
+                <a:spcPts val="0"/>
+              </a:spcBef>
+              <a:defRPr b="1" sz="3000"/>
+            </a:lvl3pPr>
+            <a:lvl4pPr marL="2209800" indent="-381000" defTabSz="701675">
+              <a:lnSpc>
+                <a:spcPct val="100000"/>
+              </a:lnSpc>
+              <a:spcBef>
+                <a:spcPts val="0"/>
+              </a:spcBef>
+              <a:defRPr b="1" sz="3000"/>
+            </a:lvl4pPr>
+            <a:lvl5pPr marL="2819400" indent="-381000" defTabSz="701675">
+              <a:lnSpc>
+                <a:spcPct val="100000"/>
+              </a:lnSpc>
+              <a:spcBef>
+                <a:spcPts val="0"/>
+              </a:spcBef>
+              <a:defRPr b="1" sz="3000"/>
+            </a:lvl5pPr>
           </a:lstStyle>
           <a:p>
             <a:pPr/>
             <a:r>
               <a:t>作者和日期</a:t>
+            </a:r>
+          </a:p>
+          <a:p>
+            <a:pPr lvl="1"/>
+            <a:r>
+              <a:t/>
+            </a:r>
+          </a:p>
+          <a:p>
+            <a:pPr lvl="2"/>
+            <a:r>
+              <a:t/>
+            </a:r>
+          </a:p>
+          <a:p>
+            <a:pPr lvl="3"/>
+            <a:r>
+              <a:t/>
+            </a:r>
+          </a:p>
+          <a:p>
+            <a:pPr lvl="4"/>
+            <a:r>
+              <a:t/>
             </a:r>
           </a:p>
         </p:txBody>
@@ -2019,20 +2111,20 @@
           <p:cNvPr id="24" name="正文级别 1…"/>
           <p:cNvSpPr txBox="1"/>
           <p:nvPr>
-            <p:ph type="body" sz="quarter" idx="1" hasCustomPrompt="1"/>
+            <p:ph type="body" sz="quarter" idx="22" hasCustomPrompt="1"/>
           </p:nvPr>
         </p:nvSpPr>
         <p:spPr>
           <a:xfrm>
-            <a:off x="1206500" y="11609910"/>
-            <a:ext cx="21971000" cy="1116952"/>
+            <a:off x="1206500" y="11609909"/>
+            <a:ext cx="21971000" cy="1116953"/>
           </a:xfrm>
           <a:prstGeom prst="rect">
             <a:avLst/>
           </a:prstGeom>
         </p:spPr>
         <p:txBody>
-          <a:bodyPr/>
+          <a:bodyPr numCol="1" spcCol="38100"/>
           <a:lstStyle>
             <a:lvl1pPr marL="0" indent="0" defTabSz="825500">
               <a:lnSpc>
@@ -2045,79 +2137,11 @@
               <a:buNone/>
               <a:defRPr b="1" sz="5500"/>
             </a:lvl1pPr>
-            <a:lvl2pPr marL="0" indent="457200" defTabSz="825500">
-              <a:lnSpc>
-                <a:spcPct val="100000"/>
-              </a:lnSpc>
-              <a:spcBef>
-                <a:spcPts val="0"/>
-              </a:spcBef>
-              <a:buSzTx/>
-              <a:buNone/>
-              <a:defRPr b="1" sz="5500"/>
-            </a:lvl2pPr>
-            <a:lvl3pPr marL="0" indent="914400" defTabSz="825500">
-              <a:lnSpc>
-                <a:spcPct val="100000"/>
-              </a:lnSpc>
-              <a:spcBef>
-                <a:spcPts val="0"/>
-              </a:spcBef>
-              <a:buSzTx/>
-              <a:buNone/>
-              <a:defRPr b="1" sz="5500"/>
-            </a:lvl3pPr>
-            <a:lvl4pPr marL="0" indent="1371600" defTabSz="825500">
-              <a:lnSpc>
-                <a:spcPct val="100000"/>
-              </a:lnSpc>
-              <a:spcBef>
-                <a:spcPts val="0"/>
-              </a:spcBef>
-              <a:buSzTx/>
-              <a:buNone/>
-              <a:defRPr b="1" sz="5500"/>
-            </a:lvl4pPr>
-            <a:lvl5pPr marL="0" indent="1828800" defTabSz="825500">
-              <a:lnSpc>
-                <a:spcPct val="100000"/>
-              </a:lnSpc>
-              <a:spcBef>
-                <a:spcPts val="0"/>
-              </a:spcBef>
-              <a:buSzTx/>
-              <a:buNone/>
-              <a:defRPr b="1" sz="5500"/>
-            </a:lvl5pPr>
           </a:lstStyle>
           <a:p>
             <a:pPr/>
             <a:r>
               <a:t>演示文稿副标题</a:t>
-            </a:r>
-          </a:p>
-          <a:p>
-            <a:pPr lvl="1"/>
-            <a:r>
-              <a:t/>
-            </a:r>
-          </a:p>
-          <a:p>
-            <a:pPr lvl="2"/>
-            <a:r>
-              <a:t/>
-            </a:r>
-          </a:p>
-          <a:p>
-            <a:pPr lvl="3"/>
-            <a:r>
-              <a:t/>
-            </a:r>
-          </a:p>
-          <a:p>
-            <a:pPr lvl="4"/>
-            <a:r>
-              <a:t/>
             </a:r>
           </a:p>
         </p:txBody>
@@ -2188,7 +2212,7 @@
           </a:prstGeom>
         </p:spPr>
         <p:txBody>
-          <a:bodyPr lIns="91439" tIns="45719" rIns="91439" bIns="45719">
+          <a:bodyPr lIns="91439" tIns="45719" rIns="91439" bIns="45719" numCol="1" spcCol="38100">
             <a:noAutofit/>
           </a:bodyPr>
           <a:lstStyle/>
@@ -2208,7 +2232,7 @@
         <p:spPr>
           <a:xfrm>
             <a:off x="1206500" y="1270000"/>
-            <a:ext cx="9779000" cy="5882273"/>
+            <a:ext cx="9779000" cy="5882274"/>
           </a:xfrm>
           <a:prstGeom prst="rect">
             <a:avLst/>
@@ -2243,7 +2267,7 @@
           </a:prstGeom>
         </p:spPr>
         <p:txBody>
-          <a:bodyPr/>
+          <a:bodyPr numCol="1" spcCol="38100"/>
           <a:lstStyle>
             <a:lvl1pPr marL="0" indent="0" defTabSz="825500">
               <a:lnSpc>
@@ -2256,7 +2280,7 @@
               <a:buNone/>
               <a:defRPr b="1" sz="5500"/>
             </a:lvl1pPr>
-            <a:lvl2pPr marL="0" indent="457200" defTabSz="825500">
+            <a:lvl2pPr marL="0" indent="0" defTabSz="825500">
               <a:lnSpc>
                 <a:spcPct val="100000"/>
               </a:lnSpc>
@@ -2267,7 +2291,7 @@
               <a:buNone/>
               <a:defRPr b="1" sz="5500"/>
             </a:lvl2pPr>
-            <a:lvl3pPr marL="0" indent="914400" defTabSz="825500">
+            <a:lvl3pPr marL="0" indent="0" defTabSz="825500">
               <a:lnSpc>
                 <a:spcPct val="100000"/>
               </a:lnSpc>
@@ -2278,7 +2302,7 @@
               <a:buNone/>
               <a:defRPr b="1" sz="5500"/>
             </a:lvl3pPr>
-            <a:lvl4pPr marL="0" indent="1371600" defTabSz="825500">
+            <a:lvl4pPr marL="0" indent="0" defTabSz="825500">
               <a:lnSpc>
                 <a:spcPct val="100000"/>
               </a:lnSpc>
@@ -2289,7 +2313,7 @@
               <a:buNone/>
               <a:defRPr b="1" sz="5500"/>
             </a:lvl4pPr>
-            <a:lvl5pPr marL="0" indent="1828800" defTabSz="825500">
+            <a:lvl5pPr marL="0" indent="0" defTabSz="825500">
               <a:lnSpc>
                 <a:spcPct val="100000"/>
               </a:lnSpc>
@@ -2343,8 +2367,8 @@
         </p:nvSpPr>
         <p:spPr>
           <a:xfrm>
-            <a:off x="12001499" y="13085233"/>
-            <a:ext cx="368505" cy="374600"/>
+            <a:off x="12001500" y="13085233"/>
+            <a:ext cx="368504" cy="374600"/>
           </a:xfrm>
           <a:prstGeom prst="rect">
             <a:avLst/>
@@ -2394,6 +2418,10 @@
           </p:nvPr>
         </p:nvSpPr>
         <p:spPr>
+          <a:xfrm>
+            <a:off x="1206500" y="1079500"/>
+            <a:ext cx="21971000" cy="1433164"/>
+          </a:xfrm>
           <a:prstGeom prst="rect">
             <a:avLst/>
           </a:prstGeom>
@@ -2411,23 +2439,23 @@
       </p:sp>
       <p:sp>
         <p:nvSpPr>
-          <p:cNvPr id="43" name="幻灯片副标题"/>
+          <p:cNvPr id="43" name="正文级别 1…"/>
           <p:cNvSpPr txBox="1"/>
           <p:nvPr>
-            <p:ph type="body" sz="quarter" idx="21" hasCustomPrompt="1"/>
+            <p:ph type="body" sz="quarter" idx="1" hasCustomPrompt="1"/>
           </p:nvPr>
         </p:nvSpPr>
         <p:spPr>
           <a:xfrm>
-            <a:off x="1206500" y="2372962"/>
-            <a:ext cx="21971000" cy="934780"/>
+            <a:off x="1206500" y="2372961"/>
+            <a:ext cx="21971000" cy="934781"/>
           </a:xfrm>
           <a:prstGeom prst="rect">
             <a:avLst/>
           </a:prstGeom>
         </p:spPr>
         <p:txBody>
-          <a:bodyPr lIns="45719" tIns="45719" rIns="45719" bIns="45719"/>
+          <a:bodyPr lIns="45718" tIns="45718" rIns="45718" bIns="45718" numCol="1" spcCol="38100"/>
           <a:lstStyle>
             <a:lvl1pPr marL="0" indent="0" defTabSz="726440">
               <a:lnSpc>
@@ -2438,13 +2466,73 @@
               </a:spcBef>
               <a:buSzTx/>
               <a:buNone/>
-              <a:defRPr b="1" sz="4840"/>
+              <a:defRPr b="1"/>
             </a:lvl1pPr>
+            <a:lvl2pPr defTabSz="726440">
+              <a:lnSpc>
+                <a:spcPct val="100000"/>
+              </a:lnSpc>
+              <a:spcBef>
+                <a:spcPts val="0"/>
+              </a:spcBef>
+              <a:defRPr b="1"/>
+            </a:lvl2pPr>
+            <a:lvl3pPr defTabSz="726440">
+              <a:lnSpc>
+                <a:spcPct val="100000"/>
+              </a:lnSpc>
+              <a:spcBef>
+                <a:spcPts val="0"/>
+              </a:spcBef>
+              <a:defRPr b="1"/>
+            </a:lvl3pPr>
+            <a:lvl4pPr defTabSz="726440">
+              <a:lnSpc>
+                <a:spcPct val="100000"/>
+              </a:lnSpc>
+              <a:spcBef>
+                <a:spcPts val="0"/>
+              </a:spcBef>
+              <a:defRPr b="1"/>
+            </a:lvl4pPr>
+            <a:lvl5pPr defTabSz="726440">
+              <a:lnSpc>
+                <a:spcPct val="100000"/>
+              </a:lnSpc>
+              <a:spcBef>
+                <a:spcPts val="0"/>
+              </a:spcBef>
+              <a:defRPr b="1"/>
+            </a:lvl5pPr>
           </a:lstStyle>
           <a:p>
             <a:pPr/>
             <a:r>
               <a:t>幻灯片副标题</a:t>
+            </a:r>
+          </a:p>
+          <a:p>
+            <a:pPr lvl="1"/>
+            <a:r>
+              <a:t/>
+            </a:r>
+          </a:p>
+          <a:p>
+            <a:pPr lvl="2"/>
+            <a:r>
+              <a:t/>
+            </a:r>
+          </a:p>
+          <a:p>
+            <a:pPr lvl="3"/>
+            <a:r>
+              <a:t/>
+            </a:r>
+          </a:p>
+          <a:p>
+            <a:pPr lvl="4"/>
+            <a:r>
+              <a:t/>
             </a:r>
           </a:p>
         </p:txBody>
@@ -2454,45 +2542,25 @@
           <p:cNvPr id="44" name="正文级别 1…"/>
           <p:cNvSpPr txBox="1"/>
           <p:nvPr>
-            <p:ph type="body" idx="1" hasCustomPrompt="1"/>
+            <p:ph type="body" idx="21" hasCustomPrompt="1"/>
           </p:nvPr>
         </p:nvSpPr>
         <p:spPr>
+          <a:xfrm>
+            <a:off x="1206500" y="4248503"/>
+            <a:ext cx="21971000" cy="8256014"/>
+          </a:xfrm>
           <a:prstGeom prst="rect">
             <a:avLst/>
           </a:prstGeom>
         </p:spPr>
         <p:txBody>
-          <a:bodyPr/>
+          <a:bodyPr numCol="1" spcCol="38100"/>
           <a:lstStyle/>
           <a:p>
             <a:pPr/>
             <a:r>
               <a:t>幻灯片项目符号文本</a:t>
-            </a:r>
-          </a:p>
-          <a:p>
-            <a:pPr lvl="1"/>
-            <a:r>
-              <a:t/>
-            </a:r>
-          </a:p>
-          <a:p>
-            <a:pPr lvl="2"/>
-            <a:r>
-              <a:t/>
-            </a:r>
-          </a:p>
-          <a:p>
-            <a:pPr lvl="3"/>
-            <a:r>
-              <a:t/>
-            </a:r>
-          </a:p>
-          <a:p>
-            <a:pPr lvl="4"/>
-            <a:r>
-              <a:t/>
             </a:r>
           </a:p>
         </p:txBody>
@@ -2559,7 +2627,7 @@
           </a:prstGeom>
         </p:spPr>
         <p:txBody>
-          <a:bodyPr numCol="2" spcCol="1098550"/>
+          <a:bodyPr/>
           <a:lstStyle/>
           <a:p>
             <a:pPr/>
@@ -2643,23 +2711,23 @@
       </p:grpSpPr>
       <p:sp>
         <p:nvSpPr>
-          <p:cNvPr id="60" name="幻灯片副标题"/>
+          <p:cNvPr id="60" name="正文级别 1…"/>
           <p:cNvSpPr txBox="1"/>
           <p:nvPr>
-            <p:ph type="body" sz="quarter" idx="21" hasCustomPrompt="1"/>
+            <p:ph type="body" sz="quarter" idx="1" hasCustomPrompt="1"/>
           </p:nvPr>
         </p:nvSpPr>
         <p:spPr>
           <a:xfrm>
-            <a:off x="1206500" y="2372962"/>
-            <a:ext cx="9779000" cy="934780"/>
+            <a:off x="1206500" y="2372961"/>
+            <a:ext cx="9779000" cy="934781"/>
           </a:xfrm>
           <a:prstGeom prst="rect">
             <a:avLst/>
           </a:prstGeom>
         </p:spPr>
         <p:txBody>
-          <a:bodyPr lIns="45719" tIns="45719" rIns="45719" bIns="45719"/>
+          <a:bodyPr lIns="45718" tIns="45718" rIns="45718" bIns="45718" numCol="1" spcCol="38100"/>
           <a:lstStyle>
             <a:lvl1pPr marL="0" indent="0" defTabSz="726440">
               <a:lnSpc>
@@ -2670,13 +2738,73 @@
               </a:spcBef>
               <a:buSzTx/>
               <a:buNone/>
-              <a:defRPr b="1" sz="4840"/>
+              <a:defRPr b="1"/>
             </a:lvl1pPr>
+            <a:lvl2pPr defTabSz="726440">
+              <a:lnSpc>
+                <a:spcPct val="100000"/>
+              </a:lnSpc>
+              <a:spcBef>
+                <a:spcPts val="0"/>
+              </a:spcBef>
+              <a:defRPr b="1"/>
+            </a:lvl2pPr>
+            <a:lvl3pPr defTabSz="726440">
+              <a:lnSpc>
+                <a:spcPct val="100000"/>
+              </a:lnSpc>
+              <a:spcBef>
+                <a:spcPts val="0"/>
+              </a:spcBef>
+              <a:defRPr b="1"/>
+            </a:lvl3pPr>
+            <a:lvl4pPr defTabSz="726440">
+              <a:lnSpc>
+                <a:spcPct val="100000"/>
+              </a:lnSpc>
+              <a:spcBef>
+                <a:spcPts val="0"/>
+              </a:spcBef>
+              <a:defRPr b="1"/>
+            </a:lvl4pPr>
+            <a:lvl5pPr defTabSz="726440">
+              <a:lnSpc>
+                <a:spcPct val="100000"/>
+              </a:lnSpc>
+              <a:spcBef>
+                <a:spcPts val="0"/>
+              </a:spcBef>
+              <a:defRPr b="1"/>
+            </a:lvl5pPr>
           </a:lstStyle>
           <a:p>
             <a:pPr/>
             <a:r>
               <a:t>幻灯片副标题</a:t>
+            </a:r>
+          </a:p>
+          <a:p>
+            <a:pPr lvl="1"/>
+            <a:r>
+              <a:t/>
+            </a:r>
+          </a:p>
+          <a:p>
+            <a:pPr lvl="2"/>
+            <a:r>
+              <a:t/>
+            </a:r>
+          </a:p>
+          <a:p>
+            <a:pPr lvl="3"/>
+            <a:r>
+              <a:t/>
+            </a:r>
+          </a:p>
+          <a:p>
+            <a:pPr lvl="4"/>
+            <a:r>
+              <a:t/>
             </a:r>
           </a:p>
         </p:txBody>
@@ -2686,49 +2814,25 @@
           <p:cNvPr id="61" name="正文级别 1…"/>
           <p:cNvSpPr txBox="1"/>
           <p:nvPr>
-            <p:ph type="body" sz="half" idx="1" hasCustomPrompt="1"/>
+            <p:ph type="body" sz="half" idx="21" hasCustomPrompt="1"/>
           </p:nvPr>
         </p:nvSpPr>
         <p:spPr>
           <a:xfrm>
-            <a:off x="1206500" y="4248504"/>
-            <a:ext cx="9779000" cy="8256630"/>
+            <a:off x="1206500" y="4248503"/>
+            <a:ext cx="9779000" cy="8256631"/>
           </a:xfrm>
           <a:prstGeom prst="rect">
             <a:avLst/>
           </a:prstGeom>
         </p:spPr>
         <p:txBody>
-          <a:bodyPr/>
+          <a:bodyPr numCol="1" spcCol="38100"/>
           <a:lstStyle/>
           <a:p>
             <a:pPr/>
             <a:r>
               <a:t>幻灯片项目符号文本</a:t>
-            </a:r>
-          </a:p>
-          <a:p>
-            <a:pPr lvl="1"/>
-            <a:r>
-              <a:t/>
-            </a:r>
-          </a:p>
-          <a:p>
-            <a:pPr lvl="2"/>
-            <a:r>
-              <a:t/>
-            </a:r>
-          </a:p>
-          <a:p>
-            <a:pPr lvl="3"/>
-            <a:r>
-              <a:t/>
-            </a:r>
-          </a:p>
-          <a:p>
-            <a:pPr lvl="4"/>
-            <a:r>
-              <a:t/>
             </a:r>
           </a:p>
         </p:txBody>
@@ -2744,14 +2848,14 @@
         <p:spPr>
           <a:xfrm>
             <a:off x="12192000" y="-407266"/>
-            <a:ext cx="10916874" cy="14555832"/>
+            <a:ext cx="10916874" cy="14555833"/>
           </a:xfrm>
           <a:prstGeom prst="rect">
             <a:avLst/>
           </a:prstGeom>
         </p:spPr>
         <p:txBody>
-          <a:bodyPr lIns="91439" tIns="45719" rIns="91439" bIns="45719">
+          <a:bodyPr lIns="91439" tIns="45719" rIns="91439" bIns="45719" numCol="1" spcCol="38100">
             <a:noAutofit/>
           </a:bodyPr>
           <a:lstStyle/>
@@ -2838,23 +2942,23 @@
       </p:grpSpPr>
       <p:sp>
         <p:nvSpPr>
-          <p:cNvPr id="71" name="幻灯片副标题"/>
+          <p:cNvPr id="71" name="正文级别 1…"/>
           <p:cNvSpPr txBox="1"/>
           <p:nvPr>
-            <p:ph type="body" sz="quarter" idx="21" hasCustomPrompt="1"/>
+            <p:ph type="body" sz="quarter" idx="1" hasCustomPrompt="1"/>
           </p:nvPr>
         </p:nvSpPr>
         <p:spPr>
           <a:xfrm>
-            <a:off x="1206500" y="2372962"/>
-            <a:ext cx="9779000" cy="934780"/>
+            <a:off x="1206500" y="2372961"/>
+            <a:ext cx="9779000" cy="934781"/>
           </a:xfrm>
           <a:prstGeom prst="rect">
             <a:avLst/>
           </a:prstGeom>
         </p:spPr>
         <p:txBody>
-          <a:bodyPr lIns="45719" tIns="45719" rIns="45719" bIns="45719"/>
+          <a:bodyPr lIns="45718" tIns="45718" rIns="45718" bIns="45718" numCol="1" spcCol="38100"/>
           <a:lstStyle>
             <a:lvl1pPr marL="0" indent="0" defTabSz="726440">
               <a:lnSpc>
@@ -2865,13 +2969,73 @@
               </a:spcBef>
               <a:buSzTx/>
               <a:buNone/>
-              <a:defRPr b="1" sz="4840"/>
+              <a:defRPr b="1"/>
             </a:lvl1pPr>
+            <a:lvl2pPr defTabSz="726440">
+              <a:lnSpc>
+                <a:spcPct val="100000"/>
+              </a:lnSpc>
+              <a:spcBef>
+                <a:spcPts val="0"/>
+              </a:spcBef>
+              <a:defRPr b="1"/>
+            </a:lvl2pPr>
+            <a:lvl3pPr defTabSz="726440">
+              <a:lnSpc>
+                <a:spcPct val="100000"/>
+              </a:lnSpc>
+              <a:spcBef>
+                <a:spcPts val="0"/>
+              </a:spcBef>
+              <a:defRPr b="1"/>
+            </a:lvl3pPr>
+            <a:lvl4pPr defTabSz="726440">
+              <a:lnSpc>
+                <a:spcPct val="100000"/>
+              </a:lnSpc>
+              <a:spcBef>
+                <a:spcPts val="0"/>
+              </a:spcBef>
+              <a:defRPr b="1"/>
+            </a:lvl4pPr>
+            <a:lvl5pPr defTabSz="726440">
+              <a:lnSpc>
+                <a:spcPct val="100000"/>
+              </a:lnSpc>
+              <a:spcBef>
+                <a:spcPts val="0"/>
+              </a:spcBef>
+              <a:defRPr b="1"/>
+            </a:lvl5pPr>
           </a:lstStyle>
           <a:p>
             <a:pPr/>
             <a:r>
               <a:t>幻灯片副标题</a:t>
+            </a:r>
+          </a:p>
+          <a:p>
+            <a:pPr lvl="1"/>
+            <a:r>
+              <a:t/>
+            </a:r>
+          </a:p>
+          <a:p>
+            <a:pPr lvl="2"/>
+            <a:r>
+              <a:t/>
+            </a:r>
+          </a:p>
+          <a:p>
+            <a:pPr lvl="3"/>
+            <a:r>
+              <a:t/>
+            </a:r>
+          </a:p>
+          <a:p>
+            <a:pPr lvl="4"/>
+            <a:r>
+              <a:t/>
             </a:r>
           </a:p>
         </p:txBody>
@@ -2881,49 +3045,25 @@
           <p:cNvPr id="72" name="正文级别 1…"/>
           <p:cNvSpPr txBox="1"/>
           <p:nvPr>
-            <p:ph type="body" sz="half" idx="1" hasCustomPrompt="1"/>
+            <p:ph type="body" sz="half" idx="21" hasCustomPrompt="1"/>
           </p:nvPr>
         </p:nvSpPr>
         <p:spPr>
           <a:xfrm>
-            <a:off x="1206500" y="4248504"/>
-            <a:ext cx="9779000" cy="8256630"/>
+            <a:off x="1206500" y="4248503"/>
+            <a:ext cx="9779000" cy="8256631"/>
           </a:xfrm>
           <a:prstGeom prst="rect">
             <a:avLst/>
           </a:prstGeom>
         </p:spPr>
         <p:txBody>
-          <a:bodyPr/>
+          <a:bodyPr numCol="1" spcCol="38100"/>
           <a:lstStyle/>
           <a:p>
             <a:pPr/>
             <a:r>
               <a:t>幻灯片项目符号文本</a:t>
-            </a:r>
-          </a:p>
-          <a:p>
-            <a:pPr lvl="1"/>
-            <a:r>
-              <a:t/>
-            </a:r>
-          </a:p>
-          <a:p>
-            <a:pPr lvl="2"/>
-            <a:r>
-              <a:t/>
-            </a:r>
-          </a:p>
-          <a:p>
-            <a:pPr lvl="3"/>
-            <a:r>
-              <a:t/>
-            </a:r>
-          </a:p>
-          <a:p>
-            <a:pPr lvl="4"/>
-            <a:r>
-              <a:t/>
             </a:r>
           </a:p>
         </p:txBody>
@@ -3006,23 +3146,23 @@
       </p:grpSpPr>
       <p:sp>
         <p:nvSpPr>
-          <p:cNvPr id="81" name="幻灯片副标题"/>
+          <p:cNvPr id="81" name="正文级别 1…"/>
           <p:cNvSpPr txBox="1"/>
           <p:nvPr>
-            <p:ph type="body" sz="quarter" idx="21" hasCustomPrompt="1"/>
+            <p:ph type="body" sz="quarter" idx="1" hasCustomPrompt="1"/>
           </p:nvPr>
         </p:nvSpPr>
         <p:spPr>
           <a:xfrm>
-            <a:off x="1206500" y="2372962"/>
-            <a:ext cx="9779000" cy="934780"/>
+            <a:off x="1206500" y="2372961"/>
+            <a:ext cx="9779000" cy="934781"/>
           </a:xfrm>
           <a:prstGeom prst="rect">
             <a:avLst/>
           </a:prstGeom>
         </p:spPr>
         <p:txBody>
-          <a:bodyPr lIns="45719" tIns="45719" rIns="45719" bIns="45719"/>
+          <a:bodyPr lIns="45718" tIns="45718" rIns="45718" bIns="45718" numCol="1" spcCol="38100"/>
           <a:lstStyle>
             <a:lvl1pPr marL="0" indent="0" defTabSz="726440">
               <a:lnSpc>
@@ -3033,13 +3173,73 @@
               </a:spcBef>
               <a:buSzTx/>
               <a:buNone/>
-              <a:defRPr b="1" sz="4840"/>
+              <a:defRPr b="1"/>
             </a:lvl1pPr>
+            <a:lvl2pPr defTabSz="726440">
+              <a:lnSpc>
+                <a:spcPct val="100000"/>
+              </a:lnSpc>
+              <a:spcBef>
+                <a:spcPts val="0"/>
+              </a:spcBef>
+              <a:defRPr b="1"/>
+            </a:lvl2pPr>
+            <a:lvl3pPr defTabSz="726440">
+              <a:lnSpc>
+                <a:spcPct val="100000"/>
+              </a:lnSpc>
+              <a:spcBef>
+                <a:spcPts val="0"/>
+              </a:spcBef>
+              <a:defRPr b="1"/>
+            </a:lvl3pPr>
+            <a:lvl4pPr defTabSz="726440">
+              <a:lnSpc>
+                <a:spcPct val="100000"/>
+              </a:lnSpc>
+              <a:spcBef>
+                <a:spcPts val="0"/>
+              </a:spcBef>
+              <a:defRPr b="1"/>
+            </a:lvl4pPr>
+            <a:lvl5pPr defTabSz="726440">
+              <a:lnSpc>
+                <a:spcPct val="100000"/>
+              </a:lnSpc>
+              <a:spcBef>
+                <a:spcPts val="0"/>
+              </a:spcBef>
+              <a:defRPr b="1"/>
+            </a:lvl5pPr>
           </a:lstStyle>
           <a:p>
             <a:pPr/>
             <a:r>
               <a:t>幻灯片副标题</a:t>
+            </a:r>
+          </a:p>
+          <a:p>
+            <a:pPr lvl="1"/>
+            <a:r>
+              <a:t/>
+            </a:r>
+          </a:p>
+          <a:p>
+            <a:pPr lvl="2"/>
+            <a:r>
+              <a:t/>
+            </a:r>
+          </a:p>
+          <a:p>
+            <a:pPr lvl="3"/>
+            <a:r>
+              <a:t/>
+            </a:r>
+          </a:p>
+          <a:p>
+            <a:pPr lvl="4"/>
+            <a:r>
+              <a:t/>
             </a:r>
           </a:p>
         </p:txBody>
@@ -3049,49 +3249,25 @@
           <p:cNvPr id="82" name="正文级别 1…"/>
           <p:cNvSpPr txBox="1"/>
           <p:nvPr>
-            <p:ph type="body" sz="half" idx="1" hasCustomPrompt="1"/>
+            <p:ph type="body" sz="half" idx="21" hasCustomPrompt="1"/>
           </p:nvPr>
         </p:nvSpPr>
         <p:spPr>
           <a:xfrm>
-            <a:off x="1206500" y="4248504"/>
-            <a:ext cx="9779000" cy="8256630"/>
+            <a:off x="1206500" y="4248503"/>
+            <a:ext cx="9779000" cy="8256631"/>
           </a:xfrm>
           <a:prstGeom prst="rect">
             <a:avLst/>
           </a:prstGeom>
         </p:spPr>
         <p:txBody>
-          <a:bodyPr/>
+          <a:bodyPr numCol="1" spcCol="38100"/>
           <a:lstStyle/>
           <a:p>
             <a:pPr/>
             <a:r>
               <a:t>幻灯片项目符号文本</a:t>
-            </a:r>
-          </a:p>
-          <a:p>
-            <a:pPr lvl="1"/>
-            <a:r>
-              <a:t/>
-            </a:r>
-          </a:p>
-          <a:p>
-            <a:pPr lvl="2"/>
-            <a:r>
-              <a:t/>
-            </a:r>
-          </a:p>
-          <a:p>
-            <a:pPr lvl="3"/>
-            <a:r>
-              <a:t/>
-            </a:r>
-          </a:p>
-          <a:p>
-            <a:pPr lvl="4"/>
-            <a:r>
-              <a:t/>
             </a:r>
           </a:p>
         </p:txBody>
@@ -3183,7 +3359,7 @@
         <p:spPr>
           <a:xfrm>
             <a:off x="1206496" y="4533900"/>
-            <a:ext cx="21971004" cy="4648200"/>
+            <a:ext cx="21971005" cy="4648200"/>
           </a:xfrm>
           <a:prstGeom prst="rect">
             <a:avLst/>
@@ -3219,8 +3395,8 @@
         </p:nvSpPr>
         <p:spPr>
           <a:xfrm>
-            <a:off x="12001499" y="13085233"/>
-            <a:ext cx="368505" cy="374600"/>
+            <a:off x="12001500" y="13085233"/>
+            <a:ext cx="368504" cy="374600"/>
           </a:xfrm>
           <a:prstGeom prst="rect">
             <a:avLst/>
@@ -3270,16 +3446,78 @@
       </p:grpSpPr>
       <p:sp>
         <p:nvSpPr>
-          <p:cNvPr id="2" name="幻灯片标题"/>
+          <p:cNvPr id="2" name="正文级别 1…"/>
           <p:cNvSpPr txBox="1"/>
           <p:nvPr>
-            <p:ph type="title" hasCustomPrompt="1"/>
+            <p:ph type="body" idx="1" hasCustomPrompt="1"/>
           </p:nvPr>
         </p:nvSpPr>
         <p:spPr>
           <a:xfrm>
-            <a:off x="1206500" y="1079500"/>
-            <a:ext cx="21971000" cy="1433163"/>
+            <a:off x="1206500" y="4248503"/>
+            <a:ext cx="21971000" cy="8256014"/>
+          </a:xfrm>
+          <a:prstGeom prst="rect">
+            <a:avLst/>
+          </a:prstGeom>
+          <a:ln w="12700">
+            <a:miter lim="400000"/>
+          </a:ln>
+          <a:extLst>
+            <a:ext uri="{C572A759-6A51-4108-AA02-DFA0A04FC94B}">
+              <ma14:wrappingTextBoxFlag xmlns:ma14="http://schemas.microsoft.com/office/mac/drawingml/2011/main" val="1"/>
+            </a:ext>
+          </a:extLst>
+        </p:spPr>
+        <p:txBody>
+          <a:bodyPr lIns="50800" tIns="50800" rIns="50800" bIns="50800" numCol="2" spcCol="1098550">
+            <a:normAutofit fontScale="100000" lnSpcReduction="0"/>
+          </a:bodyPr>
+          <a:lstStyle/>
+          <a:p>
+            <a:pPr/>
+            <a:r>
+              <a:t>幻灯片项目符号文本</a:t>
+            </a:r>
+          </a:p>
+          <a:p>
+            <a:pPr lvl="1"/>
+            <a:r>
+              <a:t/>
+            </a:r>
+          </a:p>
+          <a:p>
+            <a:pPr lvl="2"/>
+            <a:r>
+              <a:t/>
+            </a:r>
+          </a:p>
+          <a:p>
+            <a:pPr lvl="3"/>
+            <a:r>
+              <a:t/>
+            </a:r>
+          </a:p>
+          <a:p>
+            <a:pPr lvl="4"/>
+            <a:r>
+              <a:t/>
+            </a:r>
+          </a:p>
+        </p:txBody>
+      </p:sp>
+      <p:sp>
+        <p:nvSpPr>
+          <p:cNvPr id="3" name="标题文本"/>
+          <p:cNvSpPr txBox="1"/>
+          <p:nvPr>
+            <p:ph type="title"/>
+          </p:nvPr>
+        </p:nvSpPr>
+        <p:spPr>
+          <a:xfrm>
+            <a:off x="3653366" y="2743200"/>
+            <a:ext cx="19507201" cy="1505304"/>
           </a:xfrm>
           <a:prstGeom prst="rect">
             <a:avLst/>
@@ -3301,69 +3539,7 @@
           <a:p>
             <a:pPr/>
             <a:r>
-              <a:t>幻灯片标题</a:t>
-            </a:r>
-          </a:p>
-        </p:txBody>
-      </p:sp>
-      <p:sp>
-        <p:nvSpPr>
-          <p:cNvPr id="3" name="正文级别 1…"/>
-          <p:cNvSpPr txBox="1"/>
-          <p:nvPr>
-            <p:ph type="body" idx="1" hasCustomPrompt="1"/>
-          </p:nvPr>
-        </p:nvSpPr>
-        <p:spPr>
-          <a:xfrm>
-            <a:off x="1206500" y="4248504"/>
-            <a:ext cx="21971000" cy="8256012"/>
-          </a:xfrm>
-          <a:prstGeom prst="rect">
-            <a:avLst/>
-          </a:prstGeom>
-          <a:ln w="12700">
-            <a:miter lim="400000"/>
-          </a:ln>
-          <a:extLst>
-            <a:ext uri="{C572A759-6A51-4108-AA02-DFA0A04FC94B}">
-              <ma14:wrappingTextBoxFlag xmlns:ma14="http://schemas.microsoft.com/office/mac/drawingml/2011/main" val="1"/>
-            </a:ext>
-          </a:extLst>
-        </p:spPr>
-        <p:txBody>
-          <a:bodyPr lIns="50800" tIns="50800" rIns="50800" bIns="50800">
-            <a:normAutofit fontScale="100000" lnSpcReduction="0"/>
-          </a:bodyPr>
-          <a:lstStyle/>
-          <a:p>
-            <a:pPr/>
-            <a:r>
-              <a:t>幻灯片项目符号文本</a:t>
-            </a:r>
-          </a:p>
-          <a:p>
-            <a:pPr lvl="1"/>
-            <a:r>
-              <a:t/>
-            </a:r>
-          </a:p>
-          <a:p>
-            <a:pPr lvl="2"/>
-            <a:r>
-              <a:t/>
-            </a:r>
-          </a:p>
-          <a:p>
-            <a:pPr lvl="3"/>
-            <a:r>
-              <a:t/>
-            </a:r>
-          </a:p>
-          <a:p>
-            <a:pPr lvl="4"/>
-            <a:r>
-              <a:t/>
+              <a:t>标题文本</a:t>
             </a:r>
           </a:p>
         </p:txBody>
@@ -3378,8 +3554,8 @@
         </p:nvSpPr>
         <p:spPr>
           <a:xfrm>
-            <a:off x="12001499" y="13080999"/>
-            <a:ext cx="368505" cy="374600"/>
+            <a:off x="12001500" y="13080999"/>
+            <a:ext cx="368504" cy="374600"/>
           </a:xfrm>
           <a:prstGeom prst="rect">
             <a:avLst/>
@@ -3434,7 +3610,7 @@
   <p:transition xmlns:p14="http://schemas.microsoft.com/office/powerpoint/2010/main" spd="med" advClick="1"/>
   <p:txStyles>
     <p:titleStyle>
-      <a:lvl1pPr marL="0" marR="0" indent="0" algn="l" defTabSz="2438338" rtl="0" latinLnBrk="0">
+      <a:lvl1pPr marL="0" marR="0" indent="0" algn="l" defTabSz="2438337" rtl="0" latinLnBrk="0">
         <a:lnSpc>
           <a:spcPct val="80000"/>
         </a:lnSpc>
@@ -3460,7 +3636,7 @@
           <a:sym typeface="Helvetica Neue"/>
         </a:defRPr>
       </a:lvl1pPr>
-      <a:lvl2pPr marL="0" marR="0" indent="457200" algn="l" defTabSz="2438338" rtl="0" latinLnBrk="0">
+      <a:lvl2pPr marL="0" marR="0" indent="0" algn="l" defTabSz="2438337" rtl="0" latinLnBrk="0">
         <a:lnSpc>
           <a:spcPct val="80000"/>
         </a:lnSpc>
@@ -3486,7 +3662,7 @@
           <a:sym typeface="Helvetica Neue"/>
         </a:defRPr>
       </a:lvl2pPr>
-      <a:lvl3pPr marL="0" marR="0" indent="914400" algn="l" defTabSz="2438338" rtl="0" latinLnBrk="0">
+      <a:lvl3pPr marL="0" marR="0" indent="0" algn="l" defTabSz="2438337" rtl="0" latinLnBrk="0">
         <a:lnSpc>
           <a:spcPct val="80000"/>
         </a:lnSpc>
@@ -3512,7 +3688,7 @@
           <a:sym typeface="Helvetica Neue"/>
         </a:defRPr>
       </a:lvl3pPr>
-      <a:lvl4pPr marL="0" marR="0" indent="1371600" algn="l" defTabSz="2438338" rtl="0" latinLnBrk="0">
+      <a:lvl4pPr marL="0" marR="0" indent="0" algn="l" defTabSz="2438337" rtl="0" latinLnBrk="0">
         <a:lnSpc>
           <a:spcPct val="80000"/>
         </a:lnSpc>
@@ -3538,7 +3714,7 @@
           <a:sym typeface="Helvetica Neue"/>
         </a:defRPr>
       </a:lvl4pPr>
-      <a:lvl5pPr marL="0" marR="0" indent="1828800" algn="l" defTabSz="2438338" rtl="0" latinLnBrk="0">
+      <a:lvl5pPr marL="0" marR="0" indent="0" algn="l" defTabSz="2438337" rtl="0" latinLnBrk="0">
         <a:lnSpc>
           <a:spcPct val="80000"/>
         </a:lnSpc>
@@ -3564,7 +3740,7 @@
           <a:sym typeface="Helvetica Neue"/>
         </a:defRPr>
       </a:lvl5pPr>
-      <a:lvl6pPr marL="0" marR="0" indent="2286000" algn="l" defTabSz="2438338" rtl="0" latinLnBrk="0">
+      <a:lvl6pPr marL="0" marR="0" indent="0" algn="l" defTabSz="2438337" rtl="0" latinLnBrk="0">
         <a:lnSpc>
           <a:spcPct val="80000"/>
         </a:lnSpc>
@@ -3590,7 +3766,7 @@
           <a:sym typeface="Helvetica Neue"/>
         </a:defRPr>
       </a:lvl6pPr>
-      <a:lvl7pPr marL="0" marR="0" indent="2743200" algn="l" defTabSz="2438338" rtl="0" latinLnBrk="0">
+      <a:lvl7pPr marL="0" marR="0" indent="0" algn="l" defTabSz="2438337" rtl="0" latinLnBrk="0">
         <a:lnSpc>
           <a:spcPct val="80000"/>
         </a:lnSpc>
@@ -3616,7 +3792,7 @@
           <a:sym typeface="Helvetica Neue"/>
         </a:defRPr>
       </a:lvl7pPr>
-      <a:lvl8pPr marL="0" marR="0" indent="3200400" algn="l" defTabSz="2438338" rtl="0" latinLnBrk="0">
+      <a:lvl8pPr marL="0" marR="0" indent="0" algn="l" defTabSz="2438337" rtl="0" latinLnBrk="0">
         <a:lnSpc>
           <a:spcPct val="80000"/>
         </a:lnSpc>
@@ -3642,7 +3818,7 @@
           <a:sym typeface="Helvetica Neue"/>
         </a:defRPr>
       </a:lvl8pPr>
-      <a:lvl9pPr marL="0" marR="0" indent="3657600" algn="l" defTabSz="2438338" rtl="0" latinLnBrk="0">
+      <a:lvl9pPr marL="0" marR="0" indent="0" algn="l" defTabSz="2438337" rtl="0" latinLnBrk="0">
         <a:lnSpc>
           <a:spcPct val="80000"/>
         </a:lnSpc>
@@ -3670,7 +3846,7 @@
       </a:lvl9pPr>
     </p:titleStyle>
     <p:bodyStyle>
-      <a:lvl1pPr marL="609600" marR="0" indent="-609600" algn="l" defTabSz="2438338" rtl="0" latinLnBrk="0">
+      <a:lvl1pPr marL="609600" marR="0" indent="-609600" algn="l" defTabSz="2438337" rtl="0" latinLnBrk="0">
         <a:lnSpc>
           <a:spcPct val="90000"/>
         </a:lnSpc>
@@ -3696,7 +3872,7 @@
           <a:sym typeface="Helvetica Neue"/>
         </a:defRPr>
       </a:lvl1pPr>
-      <a:lvl2pPr marL="1219200" marR="0" indent="-609600" algn="l" defTabSz="2438338" rtl="0" latinLnBrk="0">
+      <a:lvl2pPr marL="1219200" marR="0" indent="-609600" algn="l" defTabSz="2438337" rtl="0" latinLnBrk="0">
         <a:lnSpc>
           <a:spcPct val="90000"/>
         </a:lnSpc>
@@ -3722,7 +3898,7 @@
           <a:sym typeface="Helvetica Neue"/>
         </a:defRPr>
       </a:lvl2pPr>
-      <a:lvl3pPr marL="1828800" marR="0" indent="-609600" algn="l" defTabSz="2438338" rtl="0" latinLnBrk="0">
+      <a:lvl3pPr marL="1828800" marR="0" indent="-609600" algn="l" defTabSz="2438337" rtl="0" latinLnBrk="0">
         <a:lnSpc>
           <a:spcPct val="90000"/>
         </a:lnSpc>
@@ -3748,7 +3924,7 @@
           <a:sym typeface="Helvetica Neue"/>
         </a:defRPr>
       </a:lvl3pPr>
-      <a:lvl4pPr marL="2438400" marR="0" indent="-609600" algn="l" defTabSz="2438338" rtl="0" latinLnBrk="0">
+      <a:lvl4pPr marL="2438400" marR="0" indent="-609600" algn="l" defTabSz="2438337" rtl="0" latinLnBrk="0">
         <a:lnSpc>
           <a:spcPct val="90000"/>
         </a:lnSpc>
@@ -3774,7 +3950,7 @@
           <a:sym typeface="Helvetica Neue"/>
         </a:defRPr>
       </a:lvl4pPr>
-      <a:lvl5pPr marL="3048000" marR="0" indent="-609600" algn="l" defTabSz="2438338" rtl="0" latinLnBrk="0">
+      <a:lvl5pPr marL="3048000" marR="0" indent="-609600" algn="l" defTabSz="2438337" rtl="0" latinLnBrk="0">
         <a:lnSpc>
           <a:spcPct val="90000"/>
         </a:lnSpc>
@@ -3800,7 +3976,7 @@
           <a:sym typeface="Helvetica Neue"/>
         </a:defRPr>
       </a:lvl5pPr>
-      <a:lvl6pPr marL="3657600" marR="0" indent="-609600" algn="l" defTabSz="2438338" rtl="0" latinLnBrk="0">
+      <a:lvl6pPr marL="3657600" marR="0" indent="-609600" algn="l" defTabSz="2438337" rtl="0" latinLnBrk="0">
         <a:lnSpc>
           <a:spcPct val="90000"/>
         </a:lnSpc>
@@ -3826,7 +4002,7 @@
           <a:sym typeface="Helvetica Neue"/>
         </a:defRPr>
       </a:lvl6pPr>
-      <a:lvl7pPr marL="4267200" marR="0" indent="-609600" algn="l" defTabSz="2438338" rtl="0" latinLnBrk="0">
+      <a:lvl7pPr marL="4267200" marR="0" indent="-609600" algn="l" defTabSz="2438337" rtl="0" latinLnBrk="0">
         <a:lnSpc>
           <a:spcPct val="90000"/>
         </a:lnSpc>
@@ -3852,7 +4028,7 @@
           <a:sym typeface="Helvetica Neue"/>
         </a:defRPr>
       </a:lvl7pPr>
-      <a:lvl8pPr marL="4876800" marR="0" indent="-609600" algn="l" defTabSz="2438338" rtl="0" latinLnBrk="0">
+      <a:lvl8pPr marL="4876800" marR="0" indent="-609600" algn="l" defTabSz="2438337" rtl="0" latinLnBrk="0">
         <a:lnSpc>
           <a:spcPct val="90000"/>
         </a:lnSpc>
@@ -3878,7 +4054,7 @@
           <a:sym typeface="Helvetica Neue"/>
         </a:defRPr>
       </a:lvl8pPr>
-      <a:lvl9pPr marL="5486400" marR="0" indent="-609600" algn="l" defTabSz="2438338" rtl="0" latinLnBrk="0">
+      <a:lvl9pPr marL="5486400" marR="0" indent="-609600" algn="l" defTabSz="2438337" rtl="0" latinLnBrk="0">
         <a:lnSpc>
           <a:spcPct val="90000"/>
         </a:lnSpc>
@@ -3932,7 +4108,7 @@
           <a:sym typeface="Helvetica Neue"/>
         </a:defRPr>
       </a:lvl1pPr>
-      <a:lvl2pPr marL="0" marR="0" indent="457200" algn="ctr" defTabSz="584200" rtl="0" latinLnBrk="0">
+      <a:lvl2pPr marL="0" marR="0" indent="0" algn="ctr" defTabSz="584200" rtl="0" latinLnBrk="0">
         <a:lnSpc>
           <a:spcPct val="100000"/>
         </a:lnSpc>
@@ -3958,7 +4134,7 @@
           <a:sym typeface="Helvetica Neue"/>
         </a:defRPr>
       </a:lvl2pPr>
-      <a:lvl3pPr marL="0" marR="0" indent="914400" algn="ctr" defTabSz="584200" rtl="0" latinLnBrk="0">
+      <a:lvl3pPr marL="0" marR="0" indent="0" algn="ctr" defTabSz="584200" rtl="0" latinLnBrk="0">
         <a:lnSpc>
           <a:spcPct val="100000"/>
         </a:lnSpc>
@@ -3984,7 +4160,7 @@
           <a:sym typeface="Helvetica Neue"/>
         </a:defRPr>
       </a:lvl3pPr>
-      <a:lvl4pPr marL="0" marR="0" indent="1371600" algn="ctr" defTabSz="584200" rtl="0" latinLnBrk="0">
+      <a:lvl4pPr marL="0" marR="0" indent="0" algn="ctr" defTabSz="584200" rtl="0" latinLnBrk="0">
         <a:lnSpc>
           <a:spcPct val="100000"/>
         </a:lnSpc>
@@ -4010,7 +4186,7 @@
           <a:sym typeface="Helvetica Neue"/>
         </a:defRPr>
       </a:lvl4pPr>
-      <a:lvl5pPr marL="0" marR="0" indent="1828800" algn="ctr" defTabSz="584200" rtl="0" latinLnBrk="0">
+      <a:lvl5pPr marL="0" marR="0" indent="0" algn="ctr" defTabSz="584200" rtl="0" latinLnBrk="0">
         <a:lnSpc>
           <a:spcPct val="100000"/>
         </a:lnSpc>
@@ -4036,7 +4212,7 @@
           <a:sym typeface="Helvetica Neue"/>
         </a:defRPr>
       </a:lvl5pPr>
-      <a:lvl6pPr marL="0" marR="0" indent="2286000" algn="ctr" defTabSz="584200" rtl="0" latinLnBrk="0">
+      <a:lvl6pPr marL="0" marR="0" indent="0" algn="ctr" defTabSz="584200" rtl="0" latinLnBrk="0">
         <a:lnSpc>
           <a:spcPct val="100000"/>
         </a:lnSpc>
@@ -4062,7 +4238,7 @@
           <a:sym typeface="Helvetica Neue"/>
         </a:defRPr>
       </a:lvl6pPr>
-      <a:lvl7pPr marL="0" marR="0" indent="2743200" algn="ctr" defTabSz="584200" rtl="0" latinLnBrk="0">
+      <a:lvl7pPr marL="0" marR="0" indent="0" algn="ctr" defTabSz="584200" rtl="0" latinLnBrk="0">
         <a:lnSpc>
           <a:spcPct val="100000"/>
         </a:lnSpc>
@@ -4088,7 +4264,7 @@
           <a:sym typeface="Helvetica Neue"/>
         </a:defRPr>
       </a:lvl7pPr>
-      <a:lvl8pPr marL="0" marR="0" indent="3200400" algn="ctr" defTabSz="584200" rtl="0" latinLnBrk="0">
+      <a:lvl8pPr marL="0" marR="0" indent="0" algn="ctr" defTabSz="584200" rtl="0" latinLnBrk="0">
         <a:lnSpc>
           <a:spcPct val="100000"/>
         </a:lnSpc>
@@ -4114,7 +4290,7 @@
           <a:sym typeface="Helvetica Neue"/>
         </a:defRPr>
       </a:lvl8pPr>
-      <a:lvl9pPr marL="0" marR="0" indent="3657600" algn="ctr" defTabSz="584200" rtl="0" latinLnBrk="0">
+      <a:lvl9pPr marL="0" marR="0" indent="0" algn="ctr" defTabSz="584200" rtl="0" latinLnBrk="0">
         <a:lnSpc>
           <a:spcPct val="100000"/>
         </a:lnSpc>
@@ -4167,13 +4343,13 @@
           <p:cNvPr id="171" name="Use Cases"/>
           <p:cNvSpPr txBox="1"/>
           <p:nvPr>
-            <p:ph type="ctrTitle"/>
+            <p:ph type="title"/>
           </p:nvPr>
         </p:nvSpPr>
         <p:spPr>
           <a:xfrm>
-            <a:off x="1206498" y="-1523548"/>
-            <a:ext cx="21971004" cy="4648201"/>
+            <a:off x="1206497" y="-1523549"/>
+            <a:ext cx="21971006" cy="4648203"/>
           </a:xfrm>
           <a:prstGeom prst="rect">
             <a:avLst/>
@@ -4181,7 +4357,11 @@
         </p:spPr>
         <p:txBody>
           <a:bodyPr/>
-          <a:lstStyle/>
+          <a:lstStyle>
+            <a:lvl1pPr>
+              <a:defRPr spc="-300"/>
+            </a:lvl1pPr>
+          </a:lstStyle>
           <a:p>
             <a:pPr/>
             <a:r>
@@ -4198,8 +4378,8 @@
         </p:nvSpPr>
         <p:spPr>
           <a:xfrm>
-            <a:off x="1704632" y="4013081"/>
-            <a:ext cx="1604164" cy="808433"/>
+            <a:off x="1704631" y="4013081"/>
+            <a:ext cx="1604164" cy="808432"/>
           </a:xfrm>
           <a:prstGeom prst="rect">
             <a:avLst/>
@@ -4234,8 +4414,8 @@
         </p:nvSpPr>
         <p:spPr>
           <a:xfrm>
-            <a:off x="1348626" y="5030685"/>
-            <a:ext cx="2316176" cy="808432"/>
+            <a:off x="1348625" y="5030685"/>
+            <a:ext cx="2316177" cy="808432"/>
           </a:xfrm>
           <a:prstGeom prst="rect">
             <a:avLst/>
@@ -4270,8 +4450,8 @@
         </p:nvSpPr>
         <p:spPr>
           <a:xfrm>
-            <a:off x="1884769" y="6048289"/>
-            <a:ext cx="1243890" cy="808432"/>
+            <a:off x="1884769" y="6048288"/>
+            <a:ext cx="1243889" cy="808433"/>
           </a:xfrm>
           <a:prstGeom prst="rect">
             <a:avLst/>
@@ -4306,8 +4486,8 @@
         </p:nvSpPr>
         <p:spPr>
           <a:xfrm>
-            <a:off x="5253011" y="4013081"/>
-            <a:ext cx="3309215" cy="808433"/>
+            <a:off x="4907628" y="5030684"/>
+            <a:ext cx="3309215" cy="808432"/>
           </a:xfrm>
           <a:prstGeom prst="rect">
             <a:avLst/>
@@ -4342,8 +4522,8 @@
         </p:nvSpPr>
         <p:spPr>
           <a:xfrm>
-            <a:off x="6032080" y="5030685"/>
-            <a:ext cx="1751077" cy="808432"/>
+            <a:off x="5686697" y="6048288"/>
+            <a:ext cx="1751077" cy="808433"/>
           </a:xfrm>
           <a:prstGeom prst="rect">
             <a:avLst/>
@@ -4378,8 +4558,8 @@
         </p:nvSpPr>
         <p:spPr>
           <a:xfrm>
-            <a:off x="5547799" y="6048289"/>
-            <a:ext cx="3038552" cy="808432"/>
+            <a:off x="5042959" y="7065892"/>
+            <a:ext cx="3038553" cy="808432"/>
           </a:xfrm>
           <a:prstGeom prst="rect">
             <a:avLst/>
@@ -4426,10 +4606,10 @@
         <a:srgbClr val="FFFFFF"/>
       </a:lt1>
       <a:dk2>
-        <a:srgbClr val="5E5E5E"/>
+        <a:srgbClr val="A7A7A7"/>
       </a:dk2>
       <a:lt2>
-        <a:srgbClr val="D5D5D5"/>
+        <a:srgbClr val="535353"/>
       </a:lt2>
       <a:accent1>
         <a:srgbClr val="00A2FF"/>
@@ -4458,9 +4638,9 @@
     </a:clrScheme>
     <a:fontScheme name="21_BasicWhite">
       <a:majorFont>
-        <a:latin typeface="Helvetica Neue"/>
-        <a:ea typeface="Helvetica Neue"/>
-        <a:cs typeface="Helvetica Neue"/>
+        <a:latin typeface="Helvetica"/>
+        <a:ea typeface="Helvetica"/>
+        <a:cs typeface="Helvetica"/>
       </a:majorFont>
       <a:minorFont>
         <a:latin typeface="Helvetica Neue"/>
@@ -4606,11 +4786,14 @@
     <a:spDef>
       <a:spPr>
         <a:solidFill>
-          <a:srgbClr val="000000"/>
+          <a:srgbClr val="FFFFFF"/>
         </a:solidFill>
-        <a:ln w="12700" cap="flat">
-          <a:noFill/>
-          <a:miter lim="400000"/>
+        <a:ln w="25400" cap="flat">
+          <a:solidFill>
+            <a:schemeClr val="accent1"/>
+          </a:solidFill>
+          <a:prstDash val="solid"/>
+          <a:round/>
         </a:ln>
         <a:effectLst/>
         <a:sp3d/>
@@ -4619,12 +4802,12 @@
         <a:spAutoFit/>
       </a:bodyPr>
       <a:lstStyle>
-        <a:defPPr marL="0" marR="0" indent="0" algn="ctr" defTabSz="825500" rtl="0" fontAlgn="auto" latinLnBrk="0" hangingPunct="0">
+        <a:defPPr marL="0" marR="0" indent="0" algn="l" defTabSz="2438337" rtl="0" fontAlgn="auto" latinLnBrk="0" hangingPunct="0">
           <a:lnSpc>
-            <a:spcPct val="100000"/>
+            <a:spcPct val="90000"/>
           </a:lnSpc>
           <a:spcBef>
-            <a:spcPts val="0"/>
+            <a:spcPts val="4500"/>
           </a:spcBef>
           <a:spcAft>
             <a:spcPts val="0"/>
@@ -4634,19 +4817,19 @@
           <a:buFontTx/>
           <a:buNone/>
           <a:tabLst/>
-          <a:defRPr b="0" baseline="0" cap="none" i="0" spc="0" strike="noStrike" sz="3200" u="none" kumimoji="0" normalizeH="0">
+          <a:defRPr b="0" baseline="0" cap="none" i="0" spc="0" strike="noStrike" sz="4800" u="none" kumimoji="0" normalizeH="0">
             <a:ln>
               <a:noFill/>
             </a:ln>
             <a:solidFill>
-              <a:srgbClr val="FFFFFF"/>
+              <a:srgbClr val="000000"/>
             </a:solidFill>
             <a:effectLst/>
             <a:uFillTx/>
-            <a:latin typeface="Helvetica Neue Medium"/>
-            <a:ea typeface="Helvetica Neue Medium"/>
-            <a:cs typeface="Helvetica Neue Medium"/>
-            <a:sym typeface="Helvetica Neue Medium"/>
+            <a:latin typeface="+mn-lt"/>
+            <a:ea typeface="+mn-ea"/>
+            <a:cs typeface="+mn-cs"/>
+            <a:sym typeface="Helvetica Neue"/>
           </a:defRPr>
         </a:defPPr>
         <a:lvl1pPr marL="0" marR="0" indent="0" algn="l" defTabSz="914400" rtl="0" fontAlgn="auto" latinLnBrk="1" hangingPunct="0">
@@ -4896,10 +5079,10 @@
         <a:noFill/>
         <a:ln w="25400" cap="flat">
           <a:solidFill>
-            <a:srgbClr val="000000"/>
+            <a:schemeClr val="accent1"/>
           </a:solidFill>
           <a:prstDash val="solid"/>
-          <a:miter lim="400000"/>
+          <a:round/>
         </a:ln>
         <a:effectLst/>
         <a:sp3d/>
@@ -5190,7 +5373,7 @@
         <a:spAutoFit/>
       </a:bodyPr>
       <a:lstStyle>
-        <a:defPPr marL="0" marR="0" indent="0" algn="l" defTabSz="2438338" rtl="0" fontAlgn="auto" latinLnBrk="0" hangingPunct="0">
+        <a:defPPr marL="0" marR="0" indent="0" algn="l" defTabSz="2438337" rtl="0" fontAlgn="auto" latinLnBrk="0" hangingPunct="0">
           <a:lnSpc>
             <a:spcPct val="90000"/>
           </a:lnSpc>
@@ -5477,10 +5660,10 @@
         <a:srgbClr val="FFFFFF"/>
       </a:lt1>
       <a:dk2>
-        <a:srgbClr val="5E5E5E"/>
+        <a:srgbClr val="A7A7A7"/>
       </a:dk2>
       <a:lt2>
-        <a:srgbClr val="D5D5D5"/>
+        <a:srgbClr val="535353"/>
       </a:lt2>
       <a:accent1>
         <a:srgbClr val="00A2FF"/>
@@ -5509,9 +5692,9 @@
     </a:clrScheme>
     <a:fontScheme name="21_BasicWhite">
       <a:majorFont>
-        <a:latin typeface="Helvetica Neue"/>
-        <a:ea typeface="Helvetica Neue"/>
-        <a:cs typeface="Helvetica Neue"/>
+        <a:latin typeface="Helvetica"/>
+        <a:ea typeface="Helvetica"/>
+        <a:cs typeface="Helvetica"/>
       </a:majorFont>
       <a:minorFont>
         <a:latin typeface="Helvetica Neue"/>
@@ -5657,11 +5840,14 @@
     <a:spDef>
       <a:spPr>
         <a:solidFill>
-          <a:srgbClr val="000000"/>
+          <a:srgbClr val="FFFFFF"/>
         </a:solidFill>
-        <a:ln w="12700" cap="flat">
-          <a:noFill/>
-          <a:miter lim="400000"/>
+        <a:ln w="25400" cap="flat">
+          <a:solidFill>
+            <a:schemeClr val="accent1"/>
+          </a:solidFill>
+          <a:prstDash val="solid"/>
+          <a:round/>
         </a:ln>
         <a:effectLst/>
         <a:sp3d/>
@@ -5670,12 +5856,12 @@
         <a:spAutoFit/>
       </a:bodyPr>
       <a:lstStyle>
-        <a:defPPr marL="0" marR="0" indent="0" algn="ctr" defTabSz="825500" rtl="0" fontAlgn="auto" latinLnBrk="0" hangingPunct="0">
+        <a:defPPr marL="0" marR="0" indent="0" algn="l" defTabSz="2438337" rtl="0" fontAlgn="auto" latinLnBrk="0" hangingPunct="0">
           <a:lnSpc>
-            <a:spcPct val="100000"/>
+            <a:spcPct val="90000"/>
           </a:lnSpc>
           <a:spcBef>
-            <a:spcPts val="0"/>
+            <a:spcPts val="4500"/>
           </a:spcBef>
           <a:spcAft>
             <a:spcPts val="0"/>
@@ -5685,19 +5871,19 @@
           <a:buFontTx/>
           <a:buNone/>
           <a:tabLst/>
-          <a:defRPr b="0" baseline="0" cap="none" i="0" spc="0" strike="noStrike" sz="3200" u="none" kumimoji="0" normalizeH="0">
+          <a:defRPr b="0" baseline="0" cap="none" i="0" spc="0" strike="noStrike" sz="4800" u="none" kumimoji="0" normalizeH="0">
             <a:ln>
               <a:noFill/>
             </a:ln>
             <a:solidFill>
-              <a:srgbClr val="FFFFFF"/>
+              <a:srgbClr val="000000"/>
             </a:solidFill>
             <a:effectLst/>
             <a:uFillTx/>
-            <a:latin typeface="Helvetica Neue Medium"/>
-            <a:ea typeface="Helvetica Neue Medium"/>
-            <a:cs typeface="Helvetica Neue Medium"/>
-            <a:sym typeface="Helvetica Neue Medium"/>
+            <a:latin typeface="+mn-lt"/>
+            <a:ea typeface="+mn-ea"/>
+            <a:cs typeface="+mn-cs"/>
+            <a:sym typeface="Helvetica Neue"/>
           </a:defRPr>
         </a:defPPr>
         <a:lvl1pPr marL="0" marR="0" indent="0" algn="l" defTabSz="914400" rtl="0" fontAlgn="auto" latinLnBrk="1" hangingPunct="0">
@@ -5947,10 +6133,10 @@
         <a:noFill/>
         <a:ln w="25400" cap="flat">
           <a:solidFill>
-            <a:srgbClr val="000000"/>
+            <a:schemeClr val="accent1"/>
           </a:solidFill>
           <a:prstDash val="solid"/>
-          <a:miter lim="400000"/>
+          <a:round/>
         </a:ln>
         <a:effectLst/>
         <a:sp3d/>
@@ -6241,7 +6427,7 @@
         <a:spAutoFit/>
       </a:bodyPr>
       <a:lstStyle>
-        <a:defPPr marL="0" marR="0" indent="0" algn="l" defTabSz="2438338" rtl="0" fontAlgn="auto" latinLnBrk="0" hangingPunct="0">
+        <a:defPPr marL="0" marR="0" indent="0" algn="l" defTabSz="2438337" rtl="0" fontAlgn="auto" latinLnBrk="0" hangingPunct="0">
           <a:lnSpc>
             <a:spcPct val="90000"/>
           </a:lnSpc>

</xml_diff>

<commit_message>
add pdf experimental mode pass-through and tighten sample regression integrity
</commit_message>
<xml_diff>
--- a/samples/pptx/pptx_table_like_negative_two_column_labels.pptx
+++ b/samples/pptx/pptx_table_like_negative_two_column_labels.pptx
@@ -3097,7 +3097,7 @@
         <p:spPr>
           <a:xfrm>
             <a:off x="822960" y="548640"/>
-            <a:ext cx="7498079" cy="914400"/>
+            <a:ext cx="4572000" cy="640080"/>
           </a:xfrm>
           <a:prstGeom prst="rect">
             <a:avLst/>
@@ -3105,7 +3105,7 @@
           <a:noFill/>
         </p:spPr>
         <p:txBody>
-          <a:bodyPr wrap="none">
+          <a:bodyPr wrap="none" anchor="ctr">
             <a:spAutoFit/>
           </a:bodyPr>
           <a:lstStyle/>
@@ -3127,8 +3127,8 @@
         </p:nvSpPr>
         <p:spPr>
           <a:xfrm>
-            <a:off x="914400" y="1828800"/>
-            <a:ext cx="2743200" cy="731520"/>
+            <a:off x="1051560" y="1783080"/>
+            <a:ext cx="2148840" cy="530352"/>
           </a:xfrm>
           <a:prstGeom prst="rect">
             <a:avLst/>
@@ -3136,7 +3136,7 @@
           <a:noFill/>
         </p:spPr>
         <p:txBody>
-          <a:bodyPr wrap="none">
+          <a:bodyPr wrap="none" anchor="ctr">
             <a:spAutoFit/>
           </a:bodyPr>
           <a:lstStyle/>
@@ -3158,8 +3158,8 @@
         </p:nvSpPr>
         <p:spPr>
           <a:xfrm>
-            <a:off x="5303520" y="1901952"/>
-            <a:ext cx="2926080" cy="731520"/>
+            <a:off x="5074920" y="1783080"/>
+            <a:ext cx="2331720" cy="530352"/>
           </a:xfrm>
           <a:prstGeom prst="rect">
             <a:avLst/>
@@ -3167,7 +3167,7 @@
           <a:noFill/>
         </p:spPr>
         <p:txBody>
-          <a:bodyPr wrap="none">
+          <a:bodyPr wrap="none" anchor="ctr">
             <a:spAutoFit/>
           </a:bodyPr>
           <a:lstStyle/>
@@ -3189,8 +3189,8 @@
         </p:nvSpPr>
         <p:spPr>
           <a:xfrm>
-            <a:off x="914400" y="2926080"/>
-            <a:ext cx="2743200" cy="731520"/>
+            <a:off x="1051560" y="2834640"/>
+            <a:ext cx="2148840" cy="530352"/>
           </a:xfrm>
           <a:prstGeom prst="rect">
             <a:avLst/>
@@ -3198,7 +3198,7 @@
           <a:noFill/>
         </p:spPr>
         <p:txBody>
-          <a:bodyPr wrap="none">
+          <a:bodyPr wrap="none" anchor="ctr">
             <a:spAutoFit/>
           </a:bodyPr>
           <a:lstStyle/>
@@ -3220,8 +3220,8 @@
         </p:nvSpPr>
         <p:spPr>
           <a:xfrm>
-            <a:off x="5303520" y="2999232"/>
-            <a:ext cx="2926080" cy="731520"/>
+            <a:off x="5074920" y="2834640"/>
+            <a:ext cx="2331720" cy="530352"/>
           </a:xfrm>
           <a:prstGeom prst="rect">
             <a:avLst/>
@@ -3229,7 +3229,7 @@
           <a:noFill/>
         </p:spPr>
         <p:txBody>
-          <a:bodyPr wrap="none">
+          <a:bodyPr wrap="none" anchor="ctr">
             <a:spAutoFit/>
           </a:bodyPr>
           <a:lstStyle/>
@@ -3251,8 +3251,8 @@
         </p:nvSpPr>
         <p:spPr>
           <a:xfrm>
-            <a:off x="914400" y="4023360"/>
-            <a:ext cx="2743200" cy="731520"/>
+            <a:off x="1051560" y="3886200"/>
+            <a:ext cx="2148840" cy="530352"/>
           </a:xfrm>
           <a:prstGeom prst="rect">
             <a:avLst/>
@@ -3260,7 +3260,7 @@
           <a:noFill/>
         </p:spPr>
         <p:txBody>
-          <a:bodyPr wrap="none">
+          <a:bodyPr wrap="none" anchor="ctr">
             <a:spAutoFit/>
           </a:bodyPr>
           <a:lstStyle/>
@@ -3282,8 +3282,8 @@
         </p:nvSpPr>
         <p:spPr>
           <a:xfrm>
-            <a:off x="5303520" y="4096512"/>
-            <a:ext cx="2926080" cy="731520"/>
+            <a:off x="5074920" y="3886200"/>
+            <a:ext cx="2331720" cy="530352"/>
           </a:xfrm>
           <a:prstGeom prst="rect">
             <a:avLst/>
@@ -3291,7 +3291,7 @@
           <a:noFill/>
         </p:spPr>
         <p:txBody>
-          <a:bodyPr wrap="none">
+          <a:bodyPr wrap="none" anchor="ctr">
             <a:spAutoFit/>
           </a:bodyPr>
           <a:lstStyle/>

</xml_diff>